<commit_message>
docs: publish clean hardened reviewer artifacts
</commit_message>
<xml_diff>
--- a/review/presentation/assurance_executive_report.pptx
+++ b/review/presentation/assurance_executive_report.pptx
@@ -594,6 +594,11 @@
           </a:p>
           <a:p>
             <a:r>
+              <a:t>NOT_APPLICABLE: The relevant field does not apply; retain it distinctly from missing, untested or not-evaluable evidence.</a:t>
+            </a:r>
+          </a:p>
+          <a:p>
+            <a:r>
               <a:t>NOT_EVALUABLE: The relevant evaluation lacks a valid basis: failed reconciliation, unresolved identity, future evidence or missing expected population can prevent evidence evaluation; insufficient assurance basis or missing inherent risk prevents residual-risk evaluation.</a:t>
             </a:r>
           </a:p>
@@ -620,6 +625,11 @@
           <a:p>
             <a:r>
               <a:t>UNMAPPED: No resolved enterprise identity. Retain the test and its source records explicitly.</a:t>
+            </a:r>
+          </a:p>
+          <a:p>
+            <a:r>
+              <a:t>partial_coverage: Partial coverage can coexist with an observed EFFECTIVE result. It does not establish full evidence sufficiency or permit a residual-risk conclusion under the configured prerequisites.</a:t>
             </a:r>
           </a:p>
           <a:p>
@@ -809,6 +819,11 @@
           </a:p>
           <a:p>
             <a:r>
+              <a:t>NOT_APPLICABLE: The relevant field does not apply; retain it distinctly from missing, untested or not-evaluable evidence.</a:t>
+            </a:r>
+          </a:p>
+          <a:p>
+            <a:r>
               <a:t>NOT_EVALUABLE: The relevant evaluation lacks a valid basis: failed reconciliation, unresolved identity, future evidence or missing expected population can prevent evidence evaluation; insufficient assurance basis or missing inherent risk prevents residual-risk evaluation.</a:t>
             </a:r>
           </a:p>
@@ -835,6 +850,11 @@
           <a:p>
             <a:r>
               <a:t>UNMAPPED: No resolved enterprise identity. Retain the test and its source records explicitly.</a:t>
+            </a:r>
+          </a:p>
+          <a:p>
+            <a:r>
+              <a:t>partial_coverage: Partial coverage can coexist with an observed EFFECTIVE result. It does not establish full evidence sufficiency or permit a residual-risk conclusion under the configured prerequisites.</a:t>
             </a:r>
           </a:p>
           <a:p>
@@ -1024,6 +1044,11 @@
           </a:p>
           <a:p>
             <a:r>
+              <a:t>NOT_APPLICABLE: The relevant field does not apply; retain it distinctly from missing, untested or not-evaluable evidence.</a:t>
+            </a:r>
+          </a:p>
+          <a:p>
+            <a:r>
               <a:t>NOT_EVALUABLE: The relevant evaluation lacks a valid basis: failed reconciliation, unresolved identity, future evidence or missing expected population can prevent evidence evaluation; insufficient assurance basis or missing inherent risk prevents residual-risk evaluation.</a:t>
             </a:r>
           </a:p>
@@ -1050,6 +1075,11 @@
           <a:p>
             <a:r>
               <a:t>UNMAPPED: No resolved enterprise identity. Retain the test and its source records explicitly.</a:t>
+            </a:r>
+          </a:p>
+          <a:p>
+            <a:r>
+              <a:t>partial_coverage: Partial coverage can coexist with an observed EFFECTIVE result. It does not establish full evidence sufficiency or permit a residual-risk conclusion under the configured prerequisites.</a:t>
             </a:r>
           </a:p>
           <a:p>
@@ -1239,6 +1269,11 @@
           </a:p>
           <a:p>
             <a:r>
+              <a:t>NOT_APPLICABLE: The relevant field does not apply; retain it distinctly from missing, untested or not-evaluable evidence.</a:t>
+            </a:r>
+          </a:p>
+          <a:p>
+            <a:r>
               <a:t>NOT_EVALUABLE: The relevant evaluation lacks a valid basis: failed reconciliation, unresolved identity, future evidence or missing expected population can prevent evidence evaluation; insufficient assurance basis or missing inherent risk prevents residual-risk evaluation.</a:t>
             </a:r>
           </a:p>
@@ -1265,6 +1300,11 @@
           <a:p>
             <a:r>
               <a:t>UNMAPPED: No resolved enterprise identity. Retain the test and its source records explicitly.</a:t>
+            </a:r>
+          </a:p>
+          <a:p>
+            <a:r>
+              <a:t>partial_coverage: Partial coverage can coexist with an observed EFFECTIVE result. It does not establish full evidence sufficiency or permit a residual-risk conclusion under the configured prerequisites.</a:t>
             </a:r>
           </a:p>
           <a:p>
@@ -1454,6 +1494,11 @@
           </a:p>
           <a:p>
             <a:r>
+              <a:t>NOT_APPLICABLE: The relevant field does not apply; retain it distinctly from missing, untested or not-evaluable evidence.</a:t>
+            </a:r>
+          </a:p>
+          <a:p>
+            <a:r>
               <a:t>NOT_EVALUABLE: The relevant evaluation lacks a valid basis: failed reconciliation, unresolved identity, future evidence or missing expected population can prevent evidence evaluation; insufficient assurance basis or missing inherent risk prevents residual-risk evaluation.</a:t>
             </a:r>
           </a:p>
@@ -1480,6 +1525,11 @@
           <a:p>
             <a:r>
               <a:t>UNMAPPED: No resolved enterprise identity. Retain the test and its source records explicitly.</a:t>
+            </a:r>
+          </a:p>
+          <a:p>
+            <a:r>
+              <a:t>partial_coverage: Partial coverage can coexist with an observed EFFECTIVE result. It does not establish full evidence sufficiency or permit a residual-risk conclusion under the configured prerequisites.</a:t>
             </a:r>
           </a:p>
           <a:p>
@@ -1669,6 +1719,11 @@
           </a:p>
           <a:p>
             <a:r>
+              <a:t>NOT_APPLICABLE: The relevant field does not apply; retain it distinctly from missing, untested or not-evaluable evidence.</a:t>
+            </a:r>
+          </a:p>
+          <a:p>
+            <a:r>
               <a:t>NOT_EVALUABLE: The relevant evaluation lacks a valid basis: failed reconciliation, unresolved identity, future evidence or missing expected population can prevent evidence evaluation; insufficient assurance basis or missing inherent risk prevents residual-risk evaluation.</a:t>
             </a:r>
           </a:p>
@@ -1695,6 +1750,11 @@
           <a:p>
             <a:r>
               <a:t>UNMAPPED: No resolved enterprise identity. Retain the test and its source records explicitly.</a:t>
+            </a:r>
+          </a:p>
+          <a:p>
+            <a:r>
+              <a:t>partial_coverage: Partial coverage can coexist with an observed EFFECTIVE result. It does not establish full evidence sufficiency or permit a residual-risk conclusion under the configured prerequisites.</a:t>
             </a:r>
           </a:p>
           <a:p>
@@ -1884,6 +1944,11 @@
           </a:p>
           <a:p>
             <a:r>
+              <a:t>NOT_APPLICABLE: The relevant field does not apply; retain it distinctly from missing, untested or not-evaluable evidence.</a:t>
+            </a:r>
+          </a:p>
+          <a:p>
+            <a:r>
               <a:t>NOT_EVALUABLE: The relevant evaluation lacks a valid basis: failed reconciliation, unresolved identity, future evidence or missing expected population can prevent evidence evaluation; insufficient assurance basis or missing inherent risk prevents residual-risk evaluation.</a:t>
             </a:r>
           </a:p>
@@ -1910,6 +1975,11 @@
           <a:p>
             <a:r>
               <a:t>UNMAPPED: No resolved enterprise identity. Retain the test and its source records explicitly.</a:t>
+            </a:r>
+          </a:p>
+          <a:p>
+            <a:r>
+              <a:t>partial_coverage: Partial coverage can coexist with an observed EFFECTIVE result. It does not establish full evidence sufficiency or permit a residual-risk conclusion under the configured prerequisites.</a:t>
             </a:r>
           </a:p>
           <a:p>
@@ -2099,6 +2169,11 @@
           </a:p>
           <a:p>
             <a:r>
+              <a:t>NOT_APPLICABLE: The relevant field does not apply; retain it distinctly from missing, untested or not-evaluable evidence.</a:t>
+            </a:r>
+          </a:p>
+          <a:p>
+            <a:r>
               <a:t>NOT_EVALUABLE: The relevant evaluation lacks a valid basis: failed reconciliation, unresolved identity, future evidence or missing expected population can prevent evidence evaluation; insufficient assurance basis or missing inherent risk prevents residual-risk evaluation.</a:t>
             </a:r>
           </a:p>
@@ -2125,6 +2200,11 @@
           <a:p>
             <a:r>
               <a:t>UNMAPPED: No resolved enterprise identity. Retain the test and its source records explicitly.</a:t>
+            </a:r>
+          </a:p>
+          <a:p>
+            <a:r>
+              <a:t>partial_coverage: Partial coverage can coexist with an observed EFFECTIVE result. It does not establish full evidence sufficiency or permit a residual-risk conclusion under the configured prerequisites.</a:t>
             </a:r>
           </a:p>
           <a:p>
@@ -5175,7 +5255,7 @@
       <p:grpSpPr/>
       <p:sp>
         <p:nvSpPr>
-          <p:cNvPr id="2" name="TextBox 1"/>
+          <p:cNvPr id="2" name="TextBox 1" descr="Executive Assurance Snapshot"/>
           <p:cNvSpPr txBox="1"/>
           <p:nvPr/>
         </p:nvSpPr>
@@ -5210,7 +5290,7 @@
       </p:sp>
       <p:sp>
         <p:nvSpPr>
-          <p:cNvPr id="3" name="TextBox 2"/>
+          <p:cNvPr id="3" name="TextBox 2" descr="Decision-ready view of the current validated assurance position"/>
           <p:cNvSpPr txBox="1"/>
           <p:nvPr/>
         </p:nvSpPr>
@@ -5398,7 +5478,7 @@
       </p:sp>
       <p:sp>
         <p:nvSpPr>
-          <p:cNvPr id="7" name="TextBox 6"/>
+          <p:cNvPr id="7" name="TextBox 6" descr="Run 20261005T175406684735Z"/>
           <p:cNvSpPr txBox="1"/>
           <p:nvPr/>
         </p:nvSpPr>
@@ -5426,7 +5506,7 @@
                 </a:solidFill>
                 <a:latin typeface="Arial"/>
               </a:rPr>
-              <a:t>Run 20261005T170737325190Z</a:t>
+              <a:t>Run 20261005T175406684735Z</a:t>
             </a:r>
           </a:p>
         </p:txBody>
@@ -5881,7 +5961,7 @@
       </p:sp>
       <p:sp>
         <p:nvSpPr>
-          <p:cNvPr id="16" name="TextBox 15"/>
+          <p:cNvPr id="16" name="TextBox 15" descr="CURRENT POSITION"/>
           <p:cNvSpPr txBox="1"/>
           <p:nvPr/>
         </p:nvSpPr>
@@ -5916,7 +5996,7 @@
       </p:sp>
       <p:sp>
         <p:nvSpPr>
-          <p:cNvPr id="17" name="TextBox 16"/>
+          <p:cNvPr id="17" name="TextBox 16" descr="Three signals matter most"/>
           <p:cNvSpPr txBox="1"/>
           <p:nvPr/>
         </p:nvSpPr>
@@ -6050,7 +6130,7 @@
       </p:sp>
       <p:sp>
         <p:nvSpPr>
-          <p:cNvPr id="20" name="TextBox 19"/>
+          <p:cNvPr id="20" name="TextBox 19" descr="Coverage is usable but incomplete"/>
           <p:cNvSpPr txBox="1"/>
           <p:nvPr/>
         </p:nvSpPr>
@@ -6085,7 +6165,7 @@
       </p:sp>
       <p:sp>
         <p:nvSpPr>
-          <p:cNvPr id="21" name="TextBox 20"/>
+          <p:cNvPr id="21" name="TextBox 20" descr="5 of 9 tests have sufficient evidence. 2 rely on stale evidence and 1 remain not evaluable for evidence sufficiency."/>
           <p:cNvSpPr txBox="1"/>
           <p:nvPr/>
         </p:nvSpPr>
@@ -6208,7 +6288,7 @@
             <a:r>
               <a:rPr sz="750" b="1">
                 <a:solidFill>
-                  <a:srgbClr val="DC2626"/>
+                  <a:srgbClr val="B91C1C"/>
                 </a:solidFill>
                 <a:latin typeface="Arial"/>
               </a:rPr>
@@ -6219,7 +6299,7 @@
       </p:sp>
       <p:sp>
         <p:nvSpPr>
-          <p:cNvPr id="24" name="TextBox 23"/>
+          <p:cNvPr id="24" name="TextBox 23" descr="Residual-risk visibility is constrained"/>
           <p:cNvSpPr txBox="1"/>
           <p:nvPr/>
         </p:nvSpPr>
@@ -6254,7 +6334,7 @@
       </p:sp>
       <p:sp>
         <p:nvSpPr>
-          <p:cNvPr id="25" name="TextBox 24"/>
+          <p:cNvPr id="25" name="TextBox 24" descr="2 tests are high/critical residual risk while 4 cannot yet support a residual-risk conclusion from the available evidence."/>
           <p:cNvSpPr txBox="1"/>
           <p:nvPr/>
         </p:nvSpPr>
@@ -6377,7 +6457,7 @@
             <a:r>
               <a:rPr sz="750" b="1">
                 <a:solidFill>
-                  <a:srgbClr val="D97706"/>
+                  <a:srgbClr val="B45309"/>
                 </a:solidFill>
                 <a:latin typeface="Arial"/>
               </a:rPr>
@@ -6388,7 +6468,7 @@
       </p:sp>
       <p:sp>
         <p:nvSpPr>
-          <p:cNvPr id="28" name="TextBox 27"/>
+          <p:cNvPr id="28" name="TextBox 27" descr="Follow-up is concentrated"/>
           <p:cNvSpPr txBox="1"/>
           <p:nvPr/>
         </p:nvSpPr>
@@ -6423,7 +6503,7 @@
       </p:sp>
       <p:sp>
         <p:nvSpPr>
-          <p:cNvPr id="29" name="TextBox 28"/>
+          <p:cNvPr id="29" name="TextBox 28" descr="The current population contains 4 open findings, 1 repeat finding and 1 overdue action, enabling targeted rather than broad remediation focus."/>
           <p:cNvSpPr txBox="1"/>
           <p:nvPr/>
         </p:nvSpPr>
@@ -6458,7 +6538,7 @@
       </p:sp>
       <p:sp>
         <p:nvSpPr>
-          <p:cNvPr id="30" name="TextBox 29"/>
+          <p:cNvPr id="30" name="TextBox 29" descr="CLICK A KPI TO DRILL INTO THE RELEVANT SECTION"/>
           <p:cNvSpPr txBox="1"/>
           <p:nvPr/>
         </p:nvSpPr>
@@ -6585,7 +6665,7 @@
       </p:sp>
       <p:sp>
         <p:nvSpPr>
-          <p:cNvPr id="33" name="TextBox 32"/>
+          <p:cNvPr id="33" name="metric:assurance_tests" descr="Assurance tests: 9"/>
           <p:cNvSpPr txBox="1"/>
           <p:nvPr/>
         </p:nvSpPr>
@@ -6620,14 +6700,14 @@
       </p:sp>
       <p:sp>
         <p:nvSpPr>
-          <p:cNvPr id="34" name="TextBox 33"/>
+          <p:cNvPr id="34" name="TextBox 33" descr="Assurance tests"/>
           <p:cNvSpPr txBox="1"/>
           <p:nvPr/>
         </p:nvSpPr>
         <p:spPr>
           <a:xfrm>
             <a:off x="822959" y="5102352"/>
-            <a:ext cx="1335024" cy="210312"/>
+            <a:ext cx="1335024" cy="310896"/>
           </a:xfrm>
           <a:prstGeom prst="rect">
             <a:avLst/>
@@ -6642,7 +6722,7 @@
           <a:p>
             <a:pPr algn="l"/>
             <a:r>
-              <a:rPr sz="850" b="0">
+              <a:rPr sz="1000" b="0">
                 <a:solidFill>
                   <a:srgbClr val="5C6C82"/>
                 </a:solidFill>
@@ -6655,42 +6735,7 @@
       </p:sp>
       <p:sp>
         <p:nvSpPr>
-          <p:cNvPr id="35" name="TextBox 34"/>
-          <p:cNvSpPr txBox="1"/>
-          <p:nvPr/>
-        </p:nvSpPr>
-        <p:spPr>
-          <a:xfrm>
-            <a:off x="1627632" y="5239512"/>
-            <a:ext cx="457200" cy="155448"/>
-          </a:xfrm>
-          <a:prstGeom prst="rect">
-            <a:avLst/>
-          </a:prstGeom>
-          <a:noFill/>
-        </p:spPr>
-        <p:txBody>
-          <a:bodyPr wrap="square" lIns="9144" rIns="9144" tIns="9144" bIns="9144" anchor="t">
-            <a:spAutoFit/>
-          </a:bodyPr>
-          <a:lstStyle/>
-          <a:p>
-            <a:pPr algn="r"/>
-            <a:r>
-              <a:rPr sz="650" b="1">
-                <a:solidFill>
-                  <a:srgbClr val="2463EB"/>
-                </a:solidFill>
-                <a:latin typeface="Arial"/>
-              </a:rPr>
-              <a:t>VIEW ›</a:t>
-            </a:r>
-          </a:p>
-        </p:txBody>
-      </p:sp>
-      <p:sp>
-        <p:nvSpPr>
-          <p:cNvPr id="36" name="Rounded Rectangle 35">
+          <p:cNvPr id="35" name="Rounded Rectangle 34">
             <a:hlinkClick action="ppaction://hlinksldjump" r:id="rId3"/>
           </p:cNvPr>
           <p:cNvSpPr/>
@@ -6737,7 +6782,7 @@
       </p:sp>
       <p:sp>
         <p:nvSpPr>
-          <p:cNvPr id="37" name="Rounded Rectangle 36"/>
+          <p:cNvPr id="36" name="Rounded Rectangle 35"/>
           <p:cNvSpPr/>
           <p:nvPr/>
         </p:nvSpPr>
@@ -6750,11 +6795,11 @@
             <a:avLst/>
           </a:prstGeom>
           <a:solidFill>
-            <a:srgbClr val="16A34A"/>
+            <a:srgbClr val="15803D"/>
           </a:solidFill>
           <a:ln>
             <a:solidFill>
-              <a:srgbClr val="16A34A"/>
+              <a:srgbClr val="15803D"/>
             </a:solidFill>
           </a:ln>
         </p:spPr>
@@ -6782,7 +6827,7 @@
       </p:sp>
       <p:sp>
         <p:nvSpPr>
-          <p:cNvPr id="38" name="TextBox 37"/>
+          <p:cNvPr id="37" name="metric:sufficient_evidence" descr="Sufficient evidence: 5"/>
           <p:cNvSpPr txBox="1"/>
           <p:nvPr/>
         </p:nvSpPr>
@@ -6817,14 +6862,14 @@
       </p:sp>
       <p:sp>
         <p:nvSpPr>
-          <p:cNvPr id="39" name="TextBox 38"/>
+          <p:cNvPr id="38" name="TextBox 37" descr="Sufficient evidence"/>
           <p:cNvSpPr txBox="1"/>
           <p:nvPr/>
         </p:nvSpPr>
         <p:spPr>
           <a:xfrm>
             <a:off x="2615184" y="5102352"/>
-            <a:ext cx="1335024" cy="210312"/>
+            <a:ext cx="1335024" cy="310896"/>
           </a:xfrm>
           <a:prstGeom prst="rect">
             <a:avLst/>
@@ -6839,7 +6884,7 @@
           <a:p>
             <a:pPr algn="l"/>
             <a:r>
-              <a:rPr sz="850" b="0">
+              <a:rPr sz="1000" b="0">
                 <a:solidFill>
                   <a:srgbClr val="5C6C82"/>
                 </a:solidFill>
@@ -6852,42 +6897,7 @@
       </p:sp>
       <p:sp>
         <p:nvSpPr>
-          <p:cNvPr id="40" name="TextBox 39"/>
-          <p:cNvSpPr txBox="1"/>
-          <p:nvPr/>
-        </p:nvSpPr>
-        <p:spPr>
-          <a:xfrm>
-            <a:off x="3419856" y="5239512"/>
-            <a:ext cx="457200" cy="155448"/>
-          </a:xfrm>
-          <a:prstGeom prst="rect">
-            <a:avLst/>
-          </a:prstGeom>
-          <a:noFill/>
-        </p:spPr>
-        <p:txBody>
-          <a:bodyPr wrap="square" lIns="9144" rIns="9144" tIns="9144" bIns="9144" anchor="t">
-            <a:spAutoFit/>
-          </a:bodyPr>
-          <a:lstStyle/>
-          <a:p>
-            <a:pPr algn="r"/>
-            <a:r>
-              <a:rPr sz="650" b="1">
-                <a:solidFill>
-                  <a:srgbClr val="16A34A"/>
-                </a:solidFill>
-                <a:latin typeface="Arial"/>
-              </a:rPr>
-              <a:t>VIEW ›</a:t>
-            </a:r>
-          </a:p>
-        </p:txBody>
-      </p:sp>
-      <p:sp>
-        <p:nvSpPr>
-          <p:cNvPr id="41" name="Rounded Rectangle 40">
+          <p:cNvPr id="39" name="Rounded Rectangle 38">
             <a:hlinkClick action="ppaction://hlinksldjump" r:id="rId3"/>
           </p:cNvPr>
           <p:cNvSpPr/>
@@ -6934,7 +6944,7 @@
       </p:sp>
       <p:sp>
         <p:nvSpPr>
-          <p:cNvPr id="42" name="Rounded Rectangle 41"/>
+          <p:cNvPr id="40" name="Rounded Rectangle 39"/>
           <p:cNvSpPr/>
           <p:nvPr/>
         </p:nvSpPr>
@@ -6947,11 +6957,11 @@
             <a:avLst/>
           </a:prstGeom>
           <a:solidFill>
-            <a:srgbClr val="D97706"/>
+            <a:srgbClr val="B45309"/>
           </a:solidFill>
           <a:ln>
             <a:solidFill>
-              <a:srgbClr val="D97706"/>
+              <a:srgbClr val="B45309"/>
             </a:solidFill>
           </a:ln>
         </p:spPr>
@@ -6979,7 +6989,7 @@
       </p:sp>
       <p:sp>
         <p:nvSpPr>
-          <p:cNvPr id="43" name="TextBox 42"/>
+          <p:cNvPr id="41" name="metric:stale_evidence" descr="Stale evidence: 2"/>
           <p:cNvSpPr txBox="1"/>
           <p:nvPr/>
         </p:nvSpPr>
@@ -7014,14 +7024,14 @@
       </p:sp>
       <p:sp>
         <p:nvSpPr>
-          <p:cNvPr id="44" name="TextBox 43"/>
+          <p:cNvPr id="42" name="TextBox 41" descr="Stale evidence"/>
           <p:cNvSpPr txBox="1"/>
           <p:nvPr/>
         </p:nvSpPr>
         <p:spPr>
           <a:xfrm>
             <a:off x="4407407" y="5102352"/>
-            <a:ext cx="1335024" cy="210312"/>
+            <a:ext cx="1335024" cy="310896"/>
           </a:xfrm>
           <a:prstGeom prst="rect">
             <a:avLst/>
@@ -7036,7 +7046,7 @@
           <a:p>
             <a:pPr algn="l"/>
             <a:r>
-              <a:rPr sz="850" b="0">
+              <a:rPr sz="1000" b="0">
                 <a:solidFill>
                   <a:srgbClr val="5C6C82"/>
                 </a:solidFill>
@@ -7049,42 +7059,7 @@
       </p:sp>
       <p:sp>
         <p:nvSpPr>
-          <p:cNvPr id="45" name="TextBox 44"/>
-          <p:cNvSpPr txBox="1"/>
-          <p:nvPr/>
-        </p:nvSpPr>
-        <p:spPr>
-          <a:xfrm>
-            <a:off x="5212080" y="5239512"/>
-            <a:ext cx="457200" cy="155448"/>
-          </a:xfrm>
-          <a:prstGeom prst="rect">
-            <a:avLst/>
-          </a:prstGeom>
-          <a:noFill/>
-        </p:spPr>
-        <p:txBody>
-          <a:bodyPr wrap="square" lIns="9144" rIns="9144" tIns="9144" bIns="9144" anchor="t">
-            <a:spAutoFit/>
-          </a:bodyPr>
-          <a:lstStyle/>
-          <a:p>
-            <a:pPr algn="r"/>
-            <a:r>
-              <a:rPr sz="650" b="1">
-                <a:solidFill>
-                  <a:srgbClr val="D97706"/>
-                </a:solidFill>
-                <a:latin typeface="Arial"/>
-              </a:rPr>
-              <a:t>VIEW ›</a:t>
-            </a:r>
-          </a:p>
-        </p:txBody>
-      </p:sp>
-      <p:sp>
-        <p:nvSpPr>
-          <p:cNvPr id="46" name="Rounded Rectangle 45">
+          <p:cNvPr id="43" name="Rounded Rectangle 42">
             <a:hlinkClick action="ppaction://hlinksldjump" r:id="rId4"/>
           </p:cNvPr>
           <p:cNvSpPr/>
@@ -7131,7 +7106,7 @@
       </p:sp>
       <p:sp>
         <p:nvSpPr>
-          <p:cNvPr id="47" name="Rounded Rectangle 46"/>
+          <p:cNvPr id="44" name="Rounded Rectangle 43"/>
           <p:cNvSpPr/>
           <p:nvPr/>
         </p:nvSpPr>
@@ -7144,11 +7119,11 @@
             <a:avLst/>
           </a:prstGeom>
           <a:solidFill>
-            <a:srgbClr val="DC2626"/>
+            <a:srgbClr val="B91C1C"/>
           </a:solidFill>
           <a:ln>
             <a:solidFill>
-              <a:srgbClr val="DC2626"/>
+              <a:srgbClr val="B91C1C"/>
             </a:solidFill>
           </a:ln>
         </p:spPr>
@@ -7176,7 +7151,7 @@
       </p:sp>
       <p:sp>
         <p:nvSpPr>
-          <p:cNvPr id="48" name="TextBox 47"/>
+          <p:cNvPr id="45" name="metric:high_or_critical_residual_risk" descr="High / critical risk: 2"/>
           <p:cNvSpPr txBox="1"/>
           <p:nvPr/>
         </p:nvSpPr>
@@ -7211,14 +7186,14 @@
       </p:sp>
       <p:sp>
         <p:nvSpPr>
-          <p:cNvPr id="49" name="TextBox 48"/>
+          <p:cNvPr id="46" name="TextBox 45" descr="High / critical risk"/>
           <p:cNvSpPr txBox="1"/>
           <p:nvPr/>
         </p:nvSpPr>
         <p:spPr>
           <a:xfrm>
             <a:off x="6199631" y="5102352"/>
-            <a:ext cx="1335024" cy="210312"/>
+            <a:ext cx="1335024" cy="310896"/>
           </a:xfrm>
           <a:prstGeom prst="rect">
             <a:avLst/>
@@ -7233,7 +7208,7 @@
           <a:p>
             <a:pPr algn="l"/>
             <a:r>
-              <a:rPr sz="850" b="0">
+              <a:rPr sz="1000" b="0">
                 <a:solidFill>
                   <a:srgbClr val="5C6C82"/>
                 </a:solidFill>
@@ -7246,42 +7221,7 @@
       </p:sp>
       <p:sp>
         <p:nvSpPr>
-          <p:cNvPr id="50" name="TextBox 49"/>
-          <p:cNvSpPr txBox="1"/>
-          <p:nvPr/>
-        </p:nvSpPr>
-        <p:spPr>
-          <a:xfrm>
-            <a:off x="7004303" y="5239512"/>
-            <a:ext cx="457200" cy="155448"/>
-          </a:xfrm>
-          <a:prstGeom prst="rect">
-            <a:avLst/>
-          </a:prstGeom>
-          <a:noFill/>
-        </p:spPr>
-        <p:txBody>
-          <a:bodyPr wrap="square" lIns="9144" rIns="9144" tIns="9144" bIns="9144" anchor="t">
-            <a:spAutoFit/>
-          </a:bodyPr>
-          <a:lstStyle/>
-          <a:p>
-            <a:pPr algn="r"/>
-            <a:r>
-              <a:rPr sz="650" b="1">
-                <a:solidFill>
-                  <a:srgbClr val="DC2626"/>
-                </a:solidFill>
-                <a:latin typeface="Arial"/>
-              </a:rPr>
-              <a:t>VIEW ›</a:t>
-            </a:r>
-          </a:p>
-        </p:txBody>
-      </p:sp>
-      <p:sp>
-        <p:nvSpPr>
-          <p:cNvPr id="51" name="Rounded Rectangle 50">
+          <p:cNvPr id="47" name="Rounded Rectangle 46">
             <a:hlinkClick action="ppaction://hlinksldjump" r:id="rId5"/>
           </p:cNvPr>
           <p:cNvSpPr/>
@@ -7328,7 +7268,7 @@
       </p:sp>
       <p:sp>
         <p:nvSpPr>
-          <p:cNvPr id="52" name="Rounded Rectangle 51"/>
+          <p:cNvPr id="48" name="Rounded Rectangle 47"/>
           <p:cNvSpPr/>
           <p:nvPr/>
         </p:nvSpPr>
@@ -7373,7 +7313,7 @@
       </p:sp>
       <p:sp>
         <p:nvSpPr>
-          <p:cNvPr id="53" name="TextBox 52"/>
+          <p:cNvPr id="49" name="metric:open_findings" descr="Open findings: 4"/>
           <p:cNvSpPr txBox="1"/>
           <p:nvPr/>
         </p:nvSpPr>
@@ -7408,14 +7348,14 @@
       </p:sp>
       <p:sp>
         <p:nvSpPr>
-          <p:cNvPr id="54" name="TextBox 53"/>
+          <p:cNvPr id="50" name="TextBox 49" descr="Open findings"/>
           <p:cNvSpPr txBox="1"/>
           <p:nvPr/>
         </p:nvSpPr>
         <p:spPr>
           <a:xfrm>
             <a:off x="7991856" y="5102352"/>
-            <a:ext cx="1335024" cy="210312"/>
+            <a:ext cx="1335024" cy="310896"/>
           </a:xfrm>
           <a:prstGeom prst="rect">
             <a:avLst/>
@@ -7430,7 +7370,7 @@
           <a:p>
             <a:pPr algn="l"/>
             <a:r>
-              <a:rPr sz="850" b="0">
+              <a:rPr sz="1000" b="0">
                 <a:solidFill>
                   <a:srgbClr val="5C6C82"/>
                 </a:solidFill>
@@ -7443,42 +7383,7 @@
       </p:sp>
       <p:sp>
         <p:nvSpPr>
-          <p:cNvPr id="55" name="TextBox 54"/>
-          <p:cNvSpPr txBox="1"/>
-          <p:nvPr/>
-        </p:nvSpPr>
-        <p:spPr>
-          <a:xfrm>
-            <a:off x="8796528" y="5239512"/>
-            <a:ext cx="457200" cy="155448"/>
-          </a:xfrm>
-          <a:prstGeom prst="rect">
-            <a:avLst/>
-          </a:prstGeom>
-          <a:noFill/>
-        </p:spPr>
-        <p:txBody>
-          <a:bodyPr wrap="square" lIns="9144" rIns="9144" tIns="9144" bIns="9144" anchor="t">
-            <a:spAutoFit/>
-          </a:bodyPr>
-          <a:lstStyle/>
-          <a:p>
-            <a:pPr algn="r"/>
-            <a:r>
-              <a:rPr sz="650" b="1">
-                <a:solidFill>
-                  <a:srgbClr val="7E22CE"/>
-                </a:solidFill>
-                <a:latin typeface="Arial"/>
-              </a:rPr>
-              <a:t>VIEW ›</a:t>
-            </a:r>
-          </a:p>
-        </p:txBody>
-      </p:sp>
-      <p:sp>
-        <p:nvSpPr>
-          <p:cNvPr id="56" name="Rounded Rectangle 55">
+          <p:cNvPr id="51" name="Rounded Rectangle 50">
             <a:hlinkClick action="ppaction://hlinksldjump" r:id="rId5"/>
           </p:cNvPr>
           <p:cNvSpPr/>
@@ -7525,7 +7430,7 @@
       </p:sp>
       <p:sp>
         <p:nvSpPr>
-          <p:cNvPr id="57" name="Rounded Rectangle 56"/>
+          <p:cNvPr id="52" name="Rounded Rectangle 51"/>
           <p:cNvSpPr/>
           <p:nvPr/>
         </p:nvSpPr>
@@ -7538,11 +7443,11 @@
             <a:avLst/>
           </a:prstGeom>
           <a:solidFill>
-            <a:srgbClr val="DC2626"/>
+            <a:srgbClr val="B91C1C"/>
           </a:solidFill>
           <a:ln>
             <a:solidFill>
-              <a:srgbClr val="DC2626"/>
+              <a:srgbClr val="B91C1C"/>
             </a:solidFill>
           </a:ln>
         </p:spPr>
@@ -7570,7 +7475,7 @@
       </p:sp>
       <p:sp>
         <p:nvSpPr>
-          <p:cNvPr id="58" name="TextBox 57"/>
+          <p:cNvPr id="53" name="metric:overdue_actions" descr="Overdue actions: 1"/>
           <p:cNvSpPr txBox="1"/>
           <p:nvPr/>
         </p:nvSpPr>
@@ -7605,14 +7510,14 @@
       </p:sp>
       <p:sp>
         <p:nvSpPr>
-          <p:cNvPr id="59" name="TextBox 58"/>
+          <p:cNvPr id="54" name="TextBox 53" descr="Overdue actions"/>
           <p:cNvSpPr txBox="1"/>
           <p:nvPr/>
         </p:nvSpPr>
         <p:spPr>
           <a:xfrm>
             <a:off x="9784080" y="5102352"/>
-            <a:ext cx="1335024" cy="210312"/>
+            <a:ext cx="1335024" cy="310896"/>
           </a:xfrm>
           <a:prstGeom prst="rect">
             <a:avLst/>
@@ -7627,7 +7532,7 @@
           <a:p>
             <a:pPr algn="l"/>
             <a:r>
-              <a:rPr sz="850" b="0">
+              <a:rPr sz="1000" b="0">
                 <a:solidFill>
                   <a:srgbClr val="5C6C82"/>
                 </a:solidFill>
@@ -7640,14 +7545,14 @@
       </p:sp>
       <p:sp>
         <p:nvSpPr>
-          <p:cNvPr id="60" name="TextBox 59"/>
+          <p:cNvPr id="55" name="TextBox 54" descr="Illustrative synthetic data and methodology; not Experian internal."/>
           <p:cNvSpPr txBox="1"/>
           <p:nvPr/>
         </p:nvSpPr>
         <p:spPr>
           <a:xfrm>
-            <a:off x="10588752" y="5239512"/>
-            <a:ext cx="457200" cy="155448"/>
+            <a:off x="658368" y="5879592"/>
+            <a:ext cx="10543032" cy="219456"/>
           </a:xfrm>
           <a:prstGeom prst="rect">
             <a:avLst/>
@@ -7660,41 +7565,6 @@
           </a:bodyPr>
           <a:lstStyle/>
           <a:p>
-            <a:pPr algn="r"/>
-            <a:r>
-              <a:rPr sz="650" b="1">
-                <a:solidFill>
-                  <a:srgbClr val="DC2626"/>
-                </a:solidFill>
-                <a:latin typeface="Arial"/>
-              </a:rPr>
-              <a:t>VIEW ›</a:t>
-            </a:r>
-          </a:p>
-        </p:txBody>
-      </p:sp>
-      <p:sp>
-        <p:nvSpPr>
-          <p:cNvPr id="61" name="TextBox 60"/>
-          <p:cNvSpPr txBox="1"/>
-          <p:nvPr/>
-        </p:nvSpPr>
-        <p:spPr>
-          <a:xfrm>
-            <a:off x="658368" y="5879592"/>
-            <a:ext cx="10543032" cy="219456"/>
-          </a:xfrm>
-          <a:prstGeom prst="rect">
-            <a:avLst/>
-          </a:prstGeom>
-          <a:noFill/>
-        </p:spPr>
-        <p:txBody>
-          <a:bodyPr wrap="square" lIns="9144" rIns="9144" tIns="9144" bIns="9144" anchor="t">
-            <a:spAutoFit/>
-          </a:bodyPr>
-          <a:lstStyle/>
-          <a:p>
             <a:pPr algn="l"/>
             <a:r>
               <a:rPr sz="900" b="0">
@@ -7710,7 +7580,7 @@
       </p:sp>
       <p:sp>
         <p:nvSpPr>
-          <p:cNvPr id="62" name="Rectangle 61"/>
+          <p:cNvPr id="56" name="Rectangle 55"/>
           <p:cNvSpPr/>
           <p:nvPr/>
         </p:nvSpPr>
@@ -7755,7 +7625,7 @@
       </p:sp>
       <p:sp>
         <p:nvSpPr>
-          <p:cNvPr id="63" name="Rounded Rectangle 62">
+          <p:cNvPr id="57" name="Rounded Rectangle 56">
             <a:hlinkClick action="ppaction://hlinksldjump" r:id="rId2"/>
           </p:cNvPr>
           <p:cNvSpPr/>
@@ -7811,7 +7681,7 @@
       </p:sp>
       <p:sp>
         <p:nvSpPr>
-          <p:cNvPr id="64" name="Rounded Rectangle 63">
+          <p:cNvPr id="58" name="Rounded Rectangle 57">
             <a:hlinkClick action="ppaction://hlinksldjump" r:id="rId2"/>
           </p:cNvPr>
           <p:cNvSpPr/>
@@ -7867,7 +7737,7 @@
       </p:sp>
       <p:sp>
         <p:nvSpPr>
-          <p:cNvPr id="65" name="Rounded Rectangle 64">
+          <p:cNvPr id="59" name="Rounded Rectangle 58">
             <a:hlinkClick action="ppaction://hlinksldjump" r:id="rId8"/>
           </p:cNvPr>
           <p:cNvSpPr/>
@@ -7923,7 +7793,7 @@
       </p:sp>
       <p:sp>
         <p:nvSpPr>
-          <p:cNvPr id="66" name="Rounded Rectangle 65">
+          <p:cNvPr id="60" name="Rounded Rectangle 59">
             <a:hlinkClick action="ppaction://hlinksldjump" r:id="rId3"/>
           </p:cNvPr>
           <p:cNvSpPr/>
@@ -7979,7 +7849,7 @@
       </p:sp>
       <p:sp>
         <p:nvSpPr>
-          <p:cNvPr id="67" name="Rounded Rectangle 66">
+          <p:cNvPr id="61" name="Rounded Rectangle 60">
             <a:hlinkClick r:id="rId11"/>
           </p:cNvPr>
           <p:cNvSpPr/>
@@ -8035,7 +7905,7 @@
       </p:sp>
       <p:sp>
         <p:nvSpPr>
-          <p:cNvPr id="68" name="Rounded Rectangle 67">
+          <p:cNvPr id="62" name="Rounded Rectangle 61">
             <a:hlinkClick r:id="rId12"/>
           </p:cNvPr>
           <p:cNvSpPr/>
@@ -8091,7 +7961,7 @@
       </p:sp>
       <p:sp>
         <p:nvSpPr>
-          <p:cNvPr id="69" name="TextBox 68"/>
+          <p:cNvPr id="63" name="TextBox 62" descr="Validated publication • 2026-09-v1"/>
           <p:cNvSpPr txBox="1"/>
           <p:nvPr/>
         </p:nvSpPr>
@@ -8152,7 +8022,7 @@
       <p:grpSpPr/>
       <p:sp>
         <p:nvSpPr>
-          <p:cNvPr id="2" name="TextBox 1"/>
+          <p:cNvPr id="2" name="TextBox 1" descr="Evidence Quality"/>
           <p:cNvSpPr txBox="1"/>
           <p:nvPr/>
         </p:nvSpPr>
@@ -8187,7 +8057,7 @@
       </p:sp>
       <p:sp>
         <p:nvSpPr>
-          <p:cNvPr id="3" name="TextBox 2"/>
+          <p:cNvPr id="3" name="TextBox 2" descr="How much of the assurance conclusion is supported by usable, current evidence"/>
           <p:cNvSpPr txBox="1"/>
           <p:nvPr/>
         </p:nvSpPr>
@@ -8375,7 +8245,7 @@
       </p:sp>
       <p:sp>
         <p:nvSpPr>
-          <p:cNvPr id="7" name="TextBox 6"/>
+          <p:cNvPr id="7" name="TextBox 6" descr="Run 20261005T175406684735Z"/>
           <p:cNvSpPr txBox="1"/>
           <p:nvPr/>
         </p:nvSpPr>
@@ -8403,7 +8273,7 @@
                 </a:solidFill>
                 <a:latin typeface="Arial"/>
               </a:rPr>
-              <a:t>Run 20261005T170737325190Z</a:t>
+              <a:t>Run 20261005T175406684735Z</a:t>
             </a:r>
           </a:p>
         </p:txBody>
@@ -8858,7 +8728,7 @@
       </p:sp>
       <p:sp>
         <p:nvSpPr>
-          <p:cNvPr id="16" name="TextBox 15"/>
+          <p:cNvPr id="16" name="TextBox 15" descr="EVIDENCE SUFFICIENCY"/>
           <p:cNvSpPr txBox="1"/>
           <p:nvPr/>
         </p:nvSpPr>
@@ -8893,7 +8763,7 @@
       </p:sp>
       <p:sp>
         <p:nvSpPr>
-          <p:cNvPr id="17" name="TextBox 16"/>
+          <p:cNvPr id="17" name="TextBox 16" descr="5/9 tests currently have sufficient evidence"/>
           <p:cNvSpPr txBox="1"/>
           <p:nvPr/>
         </p:nvSpPr>
@@ -8941,11 +8811,11 @@
             <a:avLst/>
           </a:prstGeom>
           <a:solidFill>
-            <a:srgbClr val="16A34A"/>
+            <a:srgbClr val="15803D"/>
           </a:solidFill>
           <a:ln>
             <a:solidFill>
-              <a:srgbClr val="16A34A"/>
+              <a:srgbClr val="15803D"/>
             </a:solidFill>
           </a:ln>
         </p:spPr>
@@ -8973,7 +8843,7 @@
       </p:sp>
       <p:sp>
         <p:nvSpPr>
-          <p:cNvPr id="19" name="TextBox 18"/>
+          <p:cNvPr id="19" name="TextBox 18" descr="5"/>
           <p:cNvSpPr txBox="1"/>
           <p:nvPr/>
         </p:nvSpPr>
@@ -9021,11 +8891,11 @@
             <a:avLst/>
           </a:prstGeom>
           <a:solidFill>
-            <a:srgbClr val="D97706"/>
+            <a:srgbClr val="B45309"/>
           </a:solidFill>
           <a:ln>
             <a:solidFill>
-              <a:srgbClr val="D97706"/>
+              <a:srgbClr val="B45309"/>
             </a:solidFill>
           </a:ln>
         </p:spPr>
@@ -9053,7 +8923,7 @@
       </p:sp>
       <p:sp>
         <p:nvSpPr>
-          <p:cNvPr id="21" name="TextBox 20"/>
+          <p:cNvPr id="21" name="TextBox 20" descr="1"/>
           <p:cNvSpPr txBox="1"/>
           <p:nvPr/>
         </p:nvSpPr>
@@ -9101,11 +8971,11 @@
             <a:avLst/>
           </a:prstGeom>
           <a:solidFill>
-            <a:srgbClr val="DC2626"/>
+            <a:srgbClr val="B91C1C"/>
           </a:solidFill>
           <a:ln>
             <a:solidFill>
-              <a:srgbClr val="DC2626"/>
+              <a:srgbClr val="B91C1C"/>
             </a:solidFill>
           </a:ln>
         </p:spPr>
@@ -9133,7 +9003,7 @@
       </p:sp>
       <p:sp>
         <p:nvSpPr>
-          <p:cNvPr id="23" name="TextBox 22"/>
+          <p:cNvPr id="23" name="TextBox 22" descr="2"/>
           <p:cNvSpPr txBox="1"/>
           <p:nvPr/>
         </p:nvSpPr>
@@ -9213,7 +9083,7 @@
       </p:sp>
       <p:sp>
         <p:nvSpPr>
-          <p:cNvPr id="25" name="TextBox 24"/>
+          <p:cNvPr id="25" name="TextBox 24" descr="1"/>
           <p:cNvSpPr txBox="1"/>
           <p:nvPr/>
         </p:nvSpPr>
@@ -9261,11 +9131,11 @@
             <a:avLst/>
           </a:prstGeom>
           <a:solidFill>
-            <a:srgbClr val="16A34A"/>
+            <a:srgbClr val="15803D"/>
           </a:solidFill>
           <a:ln>
             <a:solidFill>
-              <a:srgbClr val="16A34A"/>
+              <a:srgbClr val="15803D"/>
             </a:solidFill>
           </a:ln>
         </p:spPr>
@@ -9293,7 +9163,7 @@
       </p:sp>
       <p:sp>
         <p:nvSpPr>
-          <p:cNvPr id="27" name="TextBox 26"/>
+          <p:cNvPr id="27" name="TextBox 26" descr="Sufficient 5"/>
           <p:cNvSpPr txBox="1"/>
           <p:nvPr/>
         </p:nvSpPr>
@@ -9341,11 +9211,11 @@
             <a:avLst/>
           </a:prstGeom>
           <a:solidFill>
-            <a:srgbClr val="D97706"/>
+            <a:srgbClr val="B45309"/>
           </a:solidFill>
           <a:ln>
             <a:solidFill>
-              <a:srgbClr val="D97706"/>
+              <a:srgbClr val="B45309"/>
             </a:solidFill>
           </a:ln>
         </p:spPr>
@@ -9373,7 +9243,7 @@
       </p:sp>
       <p:sp>
         <p:nvSpPr>
-          <p:cNvPr id="29" name="TextBox 28"/>
+          <p:cNvPr id="29" name="TextBox 28" descr="Partial 1"/>
           <p:cNvSpPr txBox="1"/>
           <p:nvPr/>
         </p:nvSpPr>
@@ -9421,11 +9291,11 @@
             <a:avLst/>
           </a:prstGeom>
           <a:solidFill>
-            <a:srgbClr val="DC2626"/>
+            <a:srgbClr val="B91C1C"/>
           </a:solidFill>
           <a:ln>
             <a:solidFill>
-              <a:srgbClr val="DC2626"/>
+              <a:srgbClr val="B91C1C"/>
             </a:solidFill>
           </a:ln>
         </p:spPr>
@@ -9453,7 +9323,7 @@
       </p:sp>
       <p:sp>
         <p:nvSpPr>
-          <p:cNvPr id="31" name="TextBox 30"/>
+          <p:cNvPr id="31" name="TextBox 30" descr="Insufficient 2"/>
           <p:cNvSpPr txBox="1"/>
           <p:nvPr/>
         </p:nvSpPr>
@@ -9533,7 +9403,7 @@
       </p:sp>
       <p:sp>
         <p:nvSpPr>
-          <p:cNvPr id="33" name="TextBox 32"/>
+          <p:cNvPr id="33" name="TextBox 32" descr="Not evaluable 1"/>
           <p:cNvSpPr txBox="1"/>
           <p:nvPr/>
         </p:nvSpPr>
@@ -9667,7 +9537,7 @@
       </p:sp>
       <p:sp>
         <p:nvSpPr>
-          <p:cNvPr id="36" name="TextBox 35"/>
+          <p:cNvPr id="36" name="TextBox 35" descr="Evidence quality is the limiting factor"/>
           <p:cNvSpPr txBox="1"/>
           <p:nvPr/>
         </p:nvSpPr>
@@ -9702,7 +9572,7 @@
       </p:sp>
       <p:sp>
         <p:nvSpPr>
-          <p:cNvPr id="37" name="TextBox 36"/>
+          <p:cNvPr id="37" name="TextBox 36" descr="The main constraint is not test volume. Stale, insufficient and not-evaluable evidence weakens the confidence of downstream control and residual-risk conclusions."/>
           <p:cNvSpPr txBox="1"/>
           <p:nvPr/>
         </p:nvSpPr>
@@ -9795,11 +9665,11 @@
             <a:avLst/>
           </a:prstGeom>
           <a:solidFill>
-            <a:srgbClr val="D97706"/>
+            <a:srgbClr val="B45309"/>
           </a:solidFill>
           <a:ln>
             <a:solidFill>
-              <a:srgbClr val="D97706"/>
+              <a:srgbClr val="B45309"/>
             </a:solidFill>
           </a:ln>
         </p:spPr>
@@ -9827,7 +9697,7 @@
       </p:sp>
       <p:sp>
         <p:nvSpPr>
-          <p:cNvPr id="40" name="TextBox 39"/>
+          <p:cNvPr id="40" name="metric:stale_evidence" descr="Tests using stale evidence: 2"/>
           <p:cNvSpPr txBox="1"/>
           <p:nvPr/>
         </p:nvSpPr>
@@ -9862,14 +9732,14 @@
       </p:sp>
       <p:sp>
         <p:nvSpPr>
-          <p:cNvPr id="41" name="TextBox 40"/>
+          <p:cNvPr id="41" name="TextBox 40" descr="Tests using stale evidence"/>
           <p:cNvSpPr txBox="1"/>
           <p:nvPr/>
         </p:nvSpPr>
         <p:spPr>
           <a:xfrm>
             <a:off x="7799831" y="4233672"/>
-            <a:ext cx="1371600" cy="210312"/>
+            <a:ext cx="1371600" cy="310896"/>
           </a:xfrm>
           <a:prstGeom prst="rect">
             <a:avLst/>
@@ -9884,7 +9754,7 @@
           <a:p>
             <a:pPr algn="l"/>
             <a:r>
-              <a:rPr sz="850" b="0">
+              <a:rPr sz="1000" b="0">
                 <a:solidFill>
                   <a:srgbClr val="5C6C82"/>
                 </a:solidFill>
@@ -9897,42 +9767,7 @@
       </p:sp>
       <p:sp>
         <p:nvSpPr>
-          <p:cNvPr id="42" name="TextBox 41"/>
-          <p:cNvSpPr txBox="1"/>
-          <p:nvPr/>
-        </p:nvSpPr>
-        <p:spPr>
-          <a:xfrm>
-            <a:off x="8641080" y="4370832"/>
-            <a:ext cx="457200" cy="155448"/>
-          </a:xfrm>
-          <a:prstGeom prst="rect">
-            <a:avLst/>
-          </a:prstGeom>
-          <a:noFill/>
-        </p:spPr>
-        <p:txBody>
-          <a:bodyPr wrap="square" lIns="9144" rIns="9144" tIns="9144" bIns="9144" anchor="t">
-            <a:spAutoFit/>
-          </a:bodyPr>
-          <a:lstStyle/>
-          <a:p>
-            <a:pPr algn="r"/>
-            <a:r>
-              <a:rPr sz="650" b="1">
-                <a:solidFill>
-                  <a:srgbClr val="D97706"/>
-                </a:solidFill>
-                <a:latin typeface="Arial"/>
-              </a:rPr>
-              <a:t>VIEW ›</a:t>
-            </a:r>
-          </a:p>
-        </p:txBody>
-      </p:sp>
-      <p:sp>
-        <p:nvSpPr>
-          <p:cNvPr id="43" name="Rounded Rectangle 42"/>
+          <p:cNvPr id="42" name="Rounded Rectangle 41"/>
           <p:cNvSpPr/>
           <p:nvPr/>
         </p:nvSpPr>
@@ -9977,7 +9812,7 @@
       </p:sp>
       <p:sp>
         <p:nvSpPr>
-          <p:cNvPr id="44" name="Rounded Rectangle 43"/>
+          <p:cNvPr id="43" name="Rounded Rectangle 42"/>
           <p:cNvSpPr/>
           <p:nvPr/>
         </p:nvSpPr>
@@ -10022,7 +9857,7 @@
       </p:sp>
       <p:sp>
         <p:nvSpPr>
-          <p:cNvPr id="45" name="TextBox 44"/>
+          <p:cNvPr id="44" name="metric:not_evaluable_evidence" descr="Evidence not evaluable: 1"/>
           <p:cNvSpPr txBox="1"/>
           <p:nvPr/>
         </p:nvSpPr>
@@ -10057,14 +9892,14 @@
       </p:sp>
       <p:sp>
         <p:nvSpPr>
-          <p:cNvPr id="46" name="TextBox 45"/>
+          <p:cNvPr id="45" name="TextBox 44" descr="Evidence not evaluable"/>
           <p:cNvSpPr txBox="1"/>
           <p:nvPr/>
         </p:nvSpPr>
         <p:spPr>
           <a:xfrm>
             <a:off x="9637776" y="4233672"/>
-            <a:ext cx="1435607" cy="210312"/>
+            <a:ext cx="1435607" cy="310896"/>
           </a:xfrm>
           <a:prstGeom prst="rect">
             <a:avLst/>
@@ -10079,7 +9914,7 @@
           <a:p>
             <a:pPr algn="l"/>
             <a:r>
-              <a:rPr sz="850" b="0">
+              <a:rPr sz="1000" b="0">
                 <a:solidFill>
                   <a:srgbClr val="5C6C82"/>
                 </a:solidFill>
@@ -10092,42 +9927,7 @@
       </p:sp>
       <p:sp>
         <p:nvSpPr>
-          <p:cNvPr id="47" name="TextBox 46"/>
-          <p:cNvSpPr txBox="1"/>
-          <p:nvPr/>
-        </p:nvSpPr>
-        <p:spPr>
-          <a:xfrm>
-            <a:off x="10543032" y="4370832"/>
-            <a:ext cx="457200" cy="155448"/>
-          </a:xfrm>
-          <a:prstGeom prst="rect">
-            <a:avLst/>
-          </a:prstGeom>
-          <a:noFill/>
-        </p:spPr>
-        <p:txBody>
-          <a:bodyPr wrap="square" lIns="9144" rIns="9144" tIns="9144" bIns="9144" anchor="t">
-            <a:spAutoFit/>
-          </a:bodyPr>
-          <a:lstStyle/>
-          <a:p>
-            <a:pPr algn="r"/>
-            <a:r>
-              <a:rPr sz="650" b="1">
-                <a:solidFill>
-                  <a:srgbClr val="7E22CE"/>
-                </a:solidFill>
-                <a:latin typeface="Arial"/>
-              </a:rPr>
-              <a:t>VIEW ›</a:t>
-            </a:r>
-          </a:p>
-        </p:txBody>
-      </p:sp>
-      <p:sp>
-        <p:nvSpPr>
-          <p:cNvPr id="48" name="Rounded Rectangle 47"/>
+          <p:cNvPr id="46" name="Rounded Rectangle 45"/>
           <p:cNvSpPr/>
           <p:nvPr/>
         </p:nvSpPr>
@@ -10172,7 +9972,7 @@
       </p:sp>
       <p:sp>
         <p:nvSpPr>
-          <p:cNvPr id="49" name="Rounded Rectangle 48"/>
+          <p:cNvPr id="47" name="Rounded Rectangle 46"/>
           <p:cNvSpPr/>
           <p:nvPr/>
         </p:nvSpPr>
@@ -10226,7 +10026,7 @@
       </p:sp>
       <p:sp>
         <p:nvSpPr>
-          <p:cNvPr id="50" name="TextBox 49"/>
+          <p:cNvPr id="48" name="TextBox 47" descr="Repair evidence before broad retesting"/>
           <p:cNvSpPr txBox="1"/>
           <p:nvPr/>
         </p:nvSpPr>
@@ -10261,7 +10061,7 @@
       </p:sp>
       <p:sp>
         <p:nvSpPr>
-          <p:cNvPr id="51" name="TextBox 50"/>
+          <p:cNvPr id="49" name="TextBox 48" descr="Refreshing stale evidence and resolving not-evaluable cases should improve both assurance confidence and the interpretability of residual risk without unnecessarily expanding scope."/>
           <p:cNvSpPr txBox="1"/>
           <p:nvPr/>
         </p:nvSpPr>
@@ -10296,7 +10096,7 @@
       </p:sp>
       <p:sp>
         <p:nvSpPr>
-          <p:cNvPr id="52" name="Rounded Rectangle 51">
+          <p:cNvPr id="50" name="Rounded Rectangle 49">
             <a:hlinkClick action="ppaction://hlinksldjump" r:id="rId4"/>
           </p:cNvPr>
           <p:cNvSpPr/>
@@ -10352,7 +10152,7 @@
       </p:sp>
       <p:sp>
         <p:nvSpPr>
-          <p:cNvPr id="53" name="TextBox 52"/>
+          <p:cNvPr id="51" name="TextBox 50" descr="How to read this: counts are tests; freshness overlaps sufficiency. Full definitions are in Notes and HTML Data &amp; Metrics."/>
           <p:cNvSpPr txBox="1"/>
           <p:nvPr/>
         </p:nvSpPr>
@@ -10387,7 +10187,7 @@
       </p:sp>
       <p:sp>
         <p:nvSpPr>
-          <p:cNvPr id="54" name="Rectangle 53"/>
+          <p:cNvPr id="52" name="Rectangle 51"/>
           <p:cNvSpPr/>
           <p:nvPr/>
         </p:nvSpPr>
@@ -10432,7 +10232,7 @@
       </p:sp>
       <p:sp>
         <p:nvSpPr>
-          <p:cNvPr id="55" name="Rounded Rectangle 54">
+          <p:cNvPr id="53" name="Rounded Rectangle 52">
             <a:hlinkClick action="ppaction://hlinksldjump" r:id="rId2"/>
           </p:cNvPr>
           <p:cNvSpPr/>
@@ -10488,7 +10288,7 @@
       </p:sp>
       <p:sp>
         <p:nvSpPr>
-          <p:cNvPr id="56" name="Rounded Rectangle 55">
+          <p:cNvPr id="54" name="Rounded Rectangle 53">
             <a:hlinkClick action="ppaction://hlinksldjump" r:id="rId2"/>
           </p:cNvPr>
           <p:cNvSpPr/>
@@ -10544,7 +10344,7 @@
       </p:sp>
       <p:sp>
         <p:nvSpPr>
-          <p:cNvPr id="57" name="Rounded Rectangle 56">
+          <p:cNvPr id="55" name="Rounded Rectangle 54">
             <a:hlinkClick action="ppaction://hlinksldjump" r:id="rId8"/>
           </p:cNvPr>
           <p:cNvSpPr/>
@@ -10600,7 +10400,7 @@
       </p:sp>
       <p:sp>
         <p:nvSpPr>
-          <p:cNvPr id="58" name="Rounded Rectangle 57">
+          <p:cNvPr id="56" name="Rounded Rectangle 55">
             <a:hlinkClick action="ppaction://hlinksldjump" r:id="rId4"/>
           </p:cNvPr>
           <p:cNvSpPr/>
@@ -10656,7 +10456,7 @@
       </p:sp>
       <p:sp>
         <p:nvSpPr>
-          <p:cNvPr id="59" name="Rounded Rectangle 58">
+          <p:cNvPr id="57" name="Rounded Rectangle 56">
             <a:hlinkClick r:id="rId11"/>
           </p:cNvPr>
           <p:cNvSpPr/>
@@ -10712,7 +10512,7 @@
       </p:sp>
       <p:sp>
         <p:nvSpPr>
-          <p:cNvPr id="60" name="Rounded Rectangle 59">
+          <p:cNvPr id="58" name="Rounded Rectangle 57">
             <a:hlinkClick r:id="rId12"/>
           </p:cNvPr>
           <p:cNvSpPr/>
@@ -10768,7 +10568,7 @@
       </p:sp>
       <p:sp>
         <p:nvSpPr>
-          <p:cNvPr id="61" name="TextBox 60"/>
+          <p:cNvPr id="59" name="TextBox 58" descr="Validated publication • 2026-09-v1"/>
           <p:cNvSpPr txBox="1"/>
           <p:nvPr/>
         </p:nvSpPr>
@@ -10829,7 +10629,7 @@
       <p:grpSpPr/>
       <p:sp>
         <p:nvSpPr>
-          <p:cNvPr id="2" name="TextBox 1"/>
+          <p:cNvPr id="2" name="TextBox 1" descr="Risk &amp; Control Position"/>
           <p:cNvSpPr txBox="1"/>
           <p:nvPr/>
         </p:nvSpPr>
@@ -10864,7 +10664,7 @@
       </p:sp>
       <p:sp>
         <p:nvSpPr>
-          <p:cNvPr id="3" name="TextBox 2"/>
+          <p:cNvPr id="3" name="TextBox 2" descr="Where risk pressure and evidence limitations concentrate by domain"/>
           <p:cNvSpPr txBox="1"/>
           <p:nvPr/>
         </p:nvSpPr>
@@ -11052,7 +10852,7 @@
       </p:sp>
       <p:sp>
         <p:nvSpPr>
-          <p:cNvPr id="7" name="TextBox 6"/>
+          <p:cNvPr id="7" name="TextBox 6" descr="Run 20261005T175406684735Z"/>
           <p:cNvSpPr txBox="1"/>
           <p:nvPr/>
         </p:nvSpPr>
@@ -11080,7 +10880,7 @@
                 </a:solidFill>
                 <a:latin typeface="Arial"/>
               </a:rPr>
-              <a:t>Run 20261005T170737325190Z</a:t>
+              <a:t>Run 20261005T175406684735Z</a:t>
             </a:r>
           </a:p>
         </p:txBody>
@@ -11535,7 +11335,7 @@
       </p:sp>
       <p:sp>
         <p:nvSpPr>
-          <p:cNvPr id="16" name="TextBox 15"/>
+          <p:cNvPr id="16" name="TextBox 15" descr="DOMAIN PROFILE"/>
           <p:cNvSpPr txBox="1"/>
           <p:nvPr/>
         </p:nvSpPr>
@@ -11570,7 +11370,7 @@
       </p:sp>
       <p:sp>
         <p:nvSpPr>
-          <p:cNvPr id="17" name="TextBox 16"/>
+          <p:cNvPr id="17" name="TextBox 16" descr="Assurance volume and pressure by risk domain"/>
           <p:cNvSpPr txBox="1"/>
           <p:nvPr/>
         </p:nvSpPr>
@@ -11605,7 +11405,7 @@
       </p:sp>
       <p:sp>
         <p:nvSpPr>
-          <p:cNvPr id="18" name="TextBox 17"/>
+          <p:cNvPr id="18" name="TextBox 17" descr="Access Management"/>
           <p:cNvSpPr txBox="1"/>
           <p:nvPr/>
         </p:nvSpPr>
@@ -11784,7 +11584,7 @@
       </p:sp>
       <p:sp>
         <p:nvSpPr>
-          <p:cNvPr id="22" name="TextBox 21"/>
+          <p:cNvPr id="22" name="TextBox 21" descr="Change &amp; Integration"/>
           <p:cNvSpPr txBox="1"/>
           <p:nvPr/>
         </p:nvSpPr>
@@ -11963,7 +11763,7 @@
       </p:sp>
       <p:sp>
         <p:nvSpPr>
-          <p:cNvPr id="26" name="TextBox 25"/>
+          <p:cNvPr id="26" name="TextBox 25" descr="Third Party"/>
           <p:cNvSpPr txBox="1"/>
           <p:nvPr/>
         </p:nvSpPr>
@@ -12142,7 +11942,7 @@
       </p:sp>
       <p:sp>
         <p:nvSpPr>
-          <p:cNvPr id="30" name="TextBox 29"/>
+          <p:cNvPr id="30" name="TextBox 29" descr="DOMAIN SIGNAL MATRIX"/>
           <p:cNvSpPr txBox="1"/>
           <p:nvPr/>
         </p:nvSpPr>
@@ -12177,7 +11977,7 @@
       </p:sp>
       <p:sp>
         <p:nvSpPr>
-          <p:cNvPr id="31" name="TextBox 30"/>
+          <p:cNvPr id="31" name="TextBox 30" descr="Domain"/>
           <p:cNvSpPr txBox="1"/>
           <p:nvPr/>
         </p:nvSpPr>
@@ -12212,7 +12012,7 @@
       </p:sp>
       <p:sp>
         <p:nvSpPr>
-          <p:cNvPr id="32" name="TextBox 31"/>
+          <p:cNvPr id="32" name="TextBox 31" descr="Evidence"/>
           <p:cNvSpPr txBox="1"/>
           <p:nvPr/>
         </p:nvSpPr>
@@ -12247,7 +12047,7 @@
       </p:sp>
       <p:sp>
         <p:nvSpPr>
-          <p:cNvPr id="33" name="TextBox 32"/>
+          <p:cNvPr id="33" name="TextBox 32" descr="Stale"/>
           <p:cNvSpPr txBox="1"/>
           <p:nvPr/>
         </p:nvSpPr>
@@ -12282,7 +12082,7 @@
       </p:sp>
       <p:sp>
         <p:nvSpPr>
-          <p:cNvPr id="34" name="TextBox 33"/>
+          <p:cNvPr id="34" name="TextBox 33" descr="High/Crit"/>
           <p:cNvSpPr txBox="1"/>
           <p:nvPr/>
         </p:nvSpPr>
@@ -12317,7 +12117,7 @@
       </p:sp>
       <p:sp>
         <p:nvSpPr>
-          <p:cNvPr id="35" name="TextBox 34"/>
+          <p:cNvPr id="35" name="TextBox 34" descr="Access Management"/>
           <p:cNvSpPr txBox="1"/>
           <p:nvPr/>
         </p:nvSpPr>
@@ -12395,7 +12195,7 @@
             <a:r>
               <a:rPr sz="750" b="1">
                 <a:solidFill>
-                  <a:srgbClr val="16A34A"/>
+                  <a:srgbClr val="15803D"/>
                 </a:solidFill>
                 <a:latin typeface="Arial"/>
               </a:rPr>
@@ -12449,7 +12249,7 @@
             <a:r>
               <a:rPr sz="750" b="1">
                 <a:solidFill>
-                  <a:srgbClr val="D97706"/>
+                  <a:srgbClr val="B45309"/>
                 </a:solidFill>
                 <a:latin typeface="Arial"/>
               </a:rPr>
@@ -12503,7 +12303,7 @@
             <a:r>
               <a:rPr sz="750" b="1">
                 <a:solidFill>
-                  <a:srgbClr val="DC2626"/>
+                  <a:srgbClr val="B91C1C"/>
                 </a:solidFill>
                 <a:latin typeface="Arial"/>
               </a:rPr>
@@ -12514,7 +12314,7 @@
       </p:sp>
       <p:sp>
         <p:nvSpPr>
-          <p:cNvPr id="39" name="TextBox 38"/>
+          <p:cNvPr id="39" name="TextBox 38" descr="Change &amp; Integration"/>
           <p:cNvSpPr txBox="1"/>
           <p:nvPr/>
         </p:nvSpPr>
@@ -12592,7 +12392,7 @@
             <a:r>
               <a:rPr sz="750" b="1">
                 <a:solidFill>
-                  <a:srgbClr val="16A34A"/>
+                  <a:srgbClr val="15803D"/>
                 </a:solidFill>
                 <a:latin typeface="Arial"/>
               </a:rPr>
@@ -12646,7 +12446,7 @@
             <a:r>
               <a:rPr sz="750" b="1">
                 <a:solidFill>
-                  <a:srgbClr val="D97706"/>
+                  <a:srgbClr val="B45309"/>
                 </a:solidFill>
                 <a:latin typeface="Arial"/>
               </a:rPr>
@@ -12700,7 +12500,7 @@
             <a:r>
               <a:rPr sz="750" b="1">
                 <a:solidFill>
-                  <a:srgbClr val="DC2626"/>
+                  <a:srgbClr val="B91C1C"/>
                 </a:solidFill>
                 <a:latin typeface="Arial"/>
               </a:rPr>
@@ -12711,7 +12511,7 @@
       </p:sp>
       <p:sp>
         <p:nvSpPr>
-          <p:cNvPr id="43" name="TextBox 42"/>
+          <p:cNvPr id="43" name="TextBox 42" descr="Third Party"/>
           <p:cNvSpPr txBox="1"/>
           <p:nvPr/>
         </p:nvSpPr>
@@ -12789,7 +12589,7 @@
             <a:r>
               <a:rPr sz="750" b="1">
                 <a:solidFill>
-                  <a:srgbClr val="16A34A"/>
+                  <a:srgbClr val="15803D"/>
                 </a:solidFill>
                 <a:latin typeface="Arial"/>
               </a:rPr>
@@ -12843,7 +12643,7 @@
             <a:r>
               <a:rPr sz="750" b="1">
                 <a:solidFill>
-                  <a:srgbClr val="D97706"/>
+                  <a:srgbClr val="B45309"/>
                 </a:solidFill>
                 <a:latin typeface="Arial"/>
               </a:rPr>
@@ -12897,7 +12697,7 @@
             <a:r>
               <a:rPr sz="750" b="1">
                 <a:solidFill>
-                  <a:srgbClr val="DC2626"/>
+                  <a:srgbClr val="B91C1C"/>
                 </a:solidFill>
                 <a:latin typeface="Arial"/>
               </a:rPr>
@@ -12996,7 +12796,7 @@
             <a:r>
               <a:rPr sz="750" b="1">
                 <a:solidFill>
-                  <a:srgbClr val="DC2626"/>
+                  <a:srgbClr val="B91C1C"/>
                 </a:solidFill>
                 <a:latin typeface="Arial"/>
               </a:rPr>
@@ -13007,7 +12807,7 @@
       </p:sp>
       <p:sp>
         <p:nvSpPr>
-          <p:cNvPr id="49" name="TextBox 48"/>
+          <p:cNvPr id="49" name="TextBox 48" descr="Highest displayed attention signal"/>
           <p:cNvSpPr txBox="1"/>
           <p:nvPr/>
         </p:nvSpPr>
@@ -13042,7 +12842,7 @@
       </p:sp>
       <p:sp>
         <p:nvSpPr>
-          <p:cNvPr id="50" name="TextBox 49"/>
+          <p:cNvPr id="50" name="TextBox 49" descr="Access Management has 1 stale-evidence and 2 high/critical residual-risk cases in the governed domain summary."/>
           <p:cNvSpPr txBox="1"/>
           <p:nvPr/>
         </p:nvSpPr>
@@ -13514,7 +13314,7 @@
       </p:sp>
       <p:sp>
         <p:nvSpPr>
-          <p:cNvPr id="59" name="TextBox 58"/>
+          <p:cNvPr id="59" name="TextBox 58" descr="Validated publication • 2026-09-v1"/>
           <p:cNvSpPr txBox="1"/>
           <p:nvPr/>
         </p:nvSpPr>
@@ -13575,7 +13375,7 @@
       <p:grpSpPr/>
       <p:sp>
         <p:nvSpPr>
-          <p:cNvPr id="2" name="TextBox 1"/>
+          <p:cNvPr id="2" name="TextBox 1" descr="Findings &amp; Remediation"/>
           <p:cNvSpPr txBox="1"/>
           <p:nvPr/>
         </p:nvSpPr>
@@ -13610,7 +13410,7 @@
       </p:sp>
       <p:sp>
         <p:nvSpPr>
-          <p:cNvPr id="3" name="TextBox 2"/>
+          <p:cNvPr id="3" name="TextBox 2" descr="What remains open, recurring or overdue and where management follow-up should focus"/>
           <p:cNvSpPr txBox="1"/>
           <p:nvPr/>
         </p:nvSpPr>
@@ -13798,7 +13598,7 @@
       </p:sp>
       <p:sp>
         <p:nvSpPr>
-          <p:cNvPr id="7" name="TextBox 6"/>
+          <p:cNvPr id="7" name="TextBox 6" descr="Run 20261005T175406684735Z"/>
           <p:cNvSpPr txBox="1"/>
           <p:nvPr/>
         </p:nvSpPr>
@@ -13826,7 +13626,7 @@
                 </a:solidFill>
                 <a:latin typeface="Arial"/>
               </a:rPr>
-              <a:t>Run 20261005T170737325190Z</a:t>
+              <a:t>Run 20261005T175406684735Z</a:t>
             </a:r>
           </a:p>
         </p:txBody>
@@ -14371,7 +14171,7 @@
       </p:sp>
       <p:sp>
         <p:nvSpPr>
-          <p:cNvPr id="18" name="TextBox 17"/>
+          <p:cNvPr id="18" name="metric:open_findings" descr="Open findings: 4"/>
           <p:cNvSpPr txBox="1"/>
           <p:nvPr/>
         </p:nvSpPr>
@@ -14406,14 +14206,14 @@
       </p:sp>
       <p:sp>
         <p:nvSpPr>
-          <p:cNvPr id="19" name="TextBox 18"/>
+          <p:cNvPr id="19" name="TextBox 18" descr="Open findings"/>
           <p:cNvSpPr txBox="1"/>
           <p:nvPr/>
         </p:nvSpPr>
         <p:spPr>
           <a:xfrm>
             <a:off x="822959" y="2295144"/>
-            <a:ext cx="1581911" cy="210312"/>
+            <a:ext cx="1581911" cy="310896"/>
           </a:xfrm>
           <a:prstGeom prst="rect">
             <a:avLst/>
@@ -14428,7 +14228,7 @@
           <a:p>
             <a:pPr algn="l"/>
             <a:r>
-              <a:rPr sz="850" b="0">
+              <a:rPr sz="1000" b="0">
                 <a:solidFill>
                   <a:srgbClr val="5C6C82"/>
                 </a:solidFill>
@@ -14441,42 +14241,7 @@
       </p:sp>
       <p:sp>
         <p:nvSpPr>
-          <p:cNvPr id="20" name="TextBox 19"/>
-          <p:cNvSpPr txBox="1"/>
-          <p:nvPr/>
-        </p:nvSpPr>
-        <p:spPr>
-          <a:xfrm>
-            <a:off x="1874519" y="2432304"/>
-            <a:ext cx="457200" cy="155448"/>
-          </a:xfrm>
-          <a:prstGeom prst="rect">
-            <a:avLst/>
-          </a:prstGeom>
-          <a:noFill/>
-        </p:spPr>
-        <p:txBody>
-          <a:bodyPr wrap="square" lIns="9144" rIns="9144" tIns="9144" bIns="9144" anchor="t">
-            <a:spAutoFit/>
-          </a:bodyPr>
-          <a:lstStyle/>
-          <a:p>
-            <a:pPr algn="r"/>
-            <a:r>
-              <a:rPr sz="650" b="1">
-                <a:solidFill>
-                  <a:srgbClr val="7E22CE"/>
-                </a:solidFill>
-                <a:latin typeface="Arial"/>
-              </a:rPr>
-              <a:t>VIEW ›</a:t>
-            </a:r>
-          </a:p>
-        </p:txBody>
-      </p:sp>
-      <p:sp>
-        <p:nvSpPr>
-          <p:cNvPr id="21" name="Rounded Rectangle 20"/>
+          <p:cNvPr id="20" name="Rounded Rectangle 19"/>
           <p:cNvSpPr/>
           <p:nvPr/>
         </p:nvSpPr>
@@ -14521,7 +14286,7 @@
       </p:sp>
       <p:sp>
         <p:nvSpPr>
-          <p:cNvPr id="22" name="Rounded Rectangle 21"/>
+          <p:cNvPr id="21" name="Rounded Rectangle 20"/>
           <p:cNvSpPr/>
           <p:nvPr/>
         </p:nvSpPr>
@@ -14534,11 +14299,11 @@
             <a:avLst/>
           </a:prstGeom>
           <a:solidFill>
-            <a:srgbClr val="D97706"/>
+            <a:srgbClr val="B45309"/>
           </a:solidFill>
           <a:ln>
             <a:solidFill>
-              <a:srgbClr val="D97706"/>
+              <a:srgbClr val="B45309"/>
             </a:solidFill>
           </a:ln>
         </p:spPr>
@@ -14566,7 +14331,7 @@
       </p:sp>
       <p:sp>
         <p:nvSpPr>
-          <p:cNvPr id="23" name="TextBox 22"/>
+          <p:cNvPr id="22" name="metric:repeat_findings" descr="Repeat findings: 1"/>
           <p:cNvSpPr txBox="1"/>
           <p:nvPr/>
         </p:nvSpPr>
@@ -14601,14 +14366,14 @@
       </p:sp>
       <p:sp>
         <p:nvSpPr>
-          <p:cNvPr id="24" name="TextBox 23"/>
+          <p:cNvPr id="23" name="TextBox 22" descr="Repeat findings"/>
           <p:cNvSpPr txBox="1"/>
           <p:nvPr/>
         </p:nvSpPr>
         <p:spPr>
           <a:xfrm>
             <a:off x="2880360" y="2295144"/>
-            <a:ext cx="1581911" cy="210312"/>
+            <a:ext cx="1581911" cy="310896"/>
           </a:xfrm>
           <a:prstGeom prst="rect">
             <a:avLst/>
@@ -14623,7 +14388,7 @@
           <a:p>
             <a:pPr algn="l"/>
             <a:r>
-              <a:rPr sz="850" b="0">
+              <a:rPr sz="1000" b="0">
                 <a:solidFill>
                   <a:srgbClr val="5C6C82"/>
                 </a:solidFill>
@@ -14636,42 +14401,7 @@
       </p:sp>
       <p:sp>
         <p:nvSpPr>
-          <p:cNvPr id="25" name="TextBox 24"/>
-          <p:cNvSpPr txBox="1"/>
-          <p:nvPr/>
-        </p:nvSpPr>
-        <p:spPr>
-          <a:xfrm>
-            <a:off x="3931920" y="2432304"/>
-            <a:ext cx="457200" cy="155448"/>
-          </a:xfrm>
-          <a:prstGeom prst="rect">
-            <a:avLst/>
-          </a:prstGeom>
-          <a:noFill/>
-        </p:spPr>
-        <p:txBody>
-          <a:bodyPr wrap="square" lIns="9144" rIns="9144" tIns="9144" bIns="9144" anchor="t">
-            <a:spAutoFit/>
-          </a:bodyPr>
-          <a:lstStyle/>
-          <a:p>
-            <a:pPr algn="r"/>
-            <a:r>
-              <a:rPr sz="650" b="1">
-                <a:solidFill>
-                  <a:srgbClr val="D97706"/>
-                </a:solidFill>
-                <a:latin typeface="Arial"/>
-              </a:rPr>
-              <a:t>VIEW ›</a:t>
-            </a:r>
-          </a:p>
-        </p:txBody>
-      </p:sp>
-      <p:sp>
-        <p:nvSpPr>
-          <p:cNvPr id="26" name="Rounded Rectangle 25"/>
+          <p:cNvPr id="24" name="Rounded Rectangle 23"/>
           <p:cNvSpPr/>
           <p:nvPr/>
         </p:nvSpPr>
@@ -14716,7 +14446,7 @@
       </p:sp>
       <p:sp>
         <p:nvSpPr>
-          <p:cNvPr id="27" name="Rounded Rectangle 26"/>
+          <p:cNvPr id="25" name="Rounded Rectangle 24"/>
           <p:cNvSpPr/>
           <p:nvPr/>
         </p:nvSpPr>
@@ -14729,11 +14459,11 @@
             <a:avLst/>
           </a:prstGeom>
           <a:solidFill>
-            <a:srgbClr val="DC2626"/>
+            <a:srgbClr val="B91C1C"/>
           </a:solidFill>
           <a:ln>
             <a:solidFill>
-              <a:srgbClr val="DC2626"/>
+              <a:srgbClr val="B91C1C"/>
             </a:solidFill>
           </a:ln>
         </p:spPr>
@@ -14761,7 +14491,7 @@
       </p:sp>
       <p:sp>
         <p:nvSpPr>
-          <p:cNvPr id="28" name="TextBox 27"/>
+          <p:cNvPr id="26" name="metric:overdue_actions" descr="Overdue actions: 1"/>
           <p:cNvSpPr txBox="1"/>
           <p:nvPr/>
         </p:nvSpPr>
@@ -14796,14 +14526,14 @@
       </p:sp>
       <p:sp>
         <p:nvSpPr>
-          <p:cNvPr id="29" name="TextBox 28"/>
+          <p:cNvPr id="27" name="TextBox 26" descr="Overdue actions"/>
           <p:cNvSpPr txBox="1"/>
           <p:nvPr/>
         </p:nvSpPr>
         <p:spPr>
           <a:xfrm>
             <a:off x="4937759" y="2295144"/>
-            <a:ext cx="1581911" cy="210312"/>
+            <a:ext cx="1581911" cy="310896"/>
           </a:xfrm>
           <a:prstGeom prst="rect">
             <a:avLst/>
@@ -14818,7 +14548,7 @@
           <a:p>
             <a:pPr algn="l"/>
             <a:r>
-              <a:rPr sz="850" b="0">
+              <a:rPr sz="1000" b="0">
                 <a:solidFill>
                   <a:srgbClr val="5C6C82"/>
                 </a:solidFill>
@@ -14831,42 +14561,7 @@
       </p:sp>
       <p:sp>
         <p:nvSpPr>
-          <p:cNvPr id="30" name="TextBox 29"/>
-          <p:cNvSpPr txBox="1"/>
-          <p:nvPr/>
-        </p:nvSpPr>
-        <p:spPr>
-          <a:xfrm>
-            <a:off x="5989320" y="2432304"/>
-            <a:ext cx="457200" cy="155448"/>
-          </a:xfrm>
-          <a:prstGeom prst="rect">
-            <a:avLst/>
-          </a:prstGeom>
-          <a:noFill/>
-        </p:spPr>
-        <p:txBody>
-          <a:bodyPr wrap="square" lIns="9144" rIns="9144" tIns="9144" bIns="9144" anchor="t">
-            <a:spAutoFit/>
-          </a:bodyPr>
-          <a:lstStyle/>
-          <a:p>
-            <a:pPr algn="r"/>
-            <a:r>
-              <a:rPr sz="650" b="1">
-                <a:solidFill>
-                  <a:srgbClr val="DC2626"/>
-                </a:solidFill>
-                <a:latin typeface="Arial"/>
-              </a:rPr>
-              <a:t>VIEW ›</a:t>
-            </a:r>
-          </a:p>
-        </p:txBody>
-      </p:sp>
-      <p:sp>
-        <p:nvSpPr>
-          <p:cNvPr id="31" name="Rounded Rectangle 30"/>
+          <p:cNvPr id="28" name="Rounded Rectangle 27"/>
           <p:cNvSpPr/>
           <p:nvPr/>
         </p:nvSpPr>
@@ -14911,7 +14606,7 @@
       </p:sp>
       <p:sp>
         <p:nvSpPr>
-          <p:cNvPr id="32" name="Rounded Rectangle 31"/>
+          <p:cNvPr id="29" name="Rounded Rectangle 28"/>
           <p:cNvSpPr/>
           <p:nvPr/>
         </p:nvSpPr>
@@ -14954,7 +14649,7 @@
             <a:r>
               <a:rPr sz="750" b="1">
                 <a:solidFill>
-                  <a:srgbClr val="D97706"/>
+                  <a:srgbClr val="B45309"/>
                 </a:solidFill>
                 <a:latin typeface="Arial"/>
               </a:rPr>
@@ -14965,7 +14660,7 @@
       </p:sp>
       <p:sp>
         <p:nvSpPr>
-          <p:cNvPr id="33" name="TextBox 32"/>
+          <p:cNvPr id="30" name="TextBox 29" descr="Persistence matters more than volume"/>
           <p:cNvSpPr txBox="1"/>
           <p:nvPr/>
         </p:nvSpPr>
@@ -15000,7 +14695,7 @@
       </p:sp>
       <p:sp>
         <p:nvSpPr>
-          <p:cNvPr id="34" name="TextBox 33"/>
+          <p:cNvPr id="31" name="TextBox 30" descr="A repeat finding and an overdue action are escalation signals: they indicate persistence or delayed remediation rather than simply a larger inventory."/>
           <p:cNvSpPr txBox="1"/>
           <p:nvPr/>
         </p:nvSpPr>
@@ -15035,7 +14730,7 @@
       </p:sp>
       <p:sp>
         <p:nvSpPr>
-          <p:cNvPr id="35" name="TextBox 34"/>
+          <p:cNvPr id="32" name="TextBox 31" descr="CURRENT MANAGEMENT ACTIONS"/>
           <p:cNvSpPr txBox="1"/>
           <p:nvPr/>
         </p:nvSpPr>
@@ -15070,7 +14765,7 @@
       </p:sp>
       <p:graphicFrame>
         <p:nvGraphicFramePr>
-          <p:cNvPr id="36" name="Table 35"/>
+          <p:cNvPr id="33" name="Table 32"/>
           <p:cNvGraphicFramePr>
             <a:graphicFrameLocks noGrp="1"/>
           </p:cNvGraphicFramePr>
@@ -15883,7 +15578,7 @@
       </p:graphicFrame>
       <p:sp>
         <p:nvSpPr>
-          <p:cNvPr id="37" name="Rounded Rectangle 36"/>
+          <p:cNvPr id="34" name="Rounded Rectangle 33"/>
           <p:cNvSpPr/>
           <p:nvPr/>
         </p:nvSpPr>
@@ -15928,7 +15623,7 @@
       </p:sp>
       <p:sp>
         <p:nvSpPr>
-          <p:cNvPr id="38" name="Rounded Rectangle 37"/>
+          <p:cNvPr id="35" name="Rounded Rectangle 34"/>
           <p:cNvSpPr/>
           <p:nvPr/>
         </p:nvSpPr>
@@ -15982,7 +15677,7 @@
       </p:sp>
       <p:sp>
         <p:nvSpPr>
-          <p:cNvPr id="39" name="TextBox 38"/>
+          <p:cNvPr id="36" name="TextBox 35" descr="Closure is not just an administrative status"/>
           <p:cNvSpPr txBox="1"/>
           <p:nvPr/>
         </p:nvSpPr>
@@ -16017,7 +15712,7 @@
       </p:sp>
       <p:sp>
         <p:nvSpPr>
-          <p:cNvPr id="40" name="TextBox 39"/>
+          <p:cNvPr id="37" name="TextBox 36" descr="Where available, closure-validation evidence should remain linked to action status so CLOSED does not become a substitute for evidence that remediation actually worked."/>
           <p:cNvSpPr txBox="1"/>
           <p:nvPr/>
         </p:nvSpPr>
@@ -16052,7 +15747,7 @@
       </p:sp>
       <p:sp>
         <p:nvSpPr>
-          <p:cNvPr id="41" name="Rounded Rectangle 40">
+          <p:cNvPr id="38" name="Rounded Rectangle 37">
             <a:hlinkClick action="ppaction://hlinksldjump" r:id="rId8"/>
           </p:cNvPr>
           <p:cNvSpPr/>
@@ -16108,7 +15803,7 @@
       </p:sp>
       <p:sp>
         <p:nvSpPr>
-          <p:cNvPr id="42" name="Rectangle 41"/>
+          <p:cNvPr id="39" name="Rectangle 38"/>
           <p:cNvSpPr/>
           <p:nvPr/>
         </p:nvSpPr>
@@ -16153,7 +15848,7 @@
       </p:sp>
       <p:sp>
         <p:nvSpPr>
-          <p:cNvPr id="43" name="Rounded Rectangle 42">
+          <p:cNvPr id="40" name="Rounded Rectangle 39">
             <a:hlinkClick action="ppaction://hlinksldjump" r:id="rId4"/>
           </p:cNvPr>
           <p:cNvSpPr/>
@@ -16209,7 +15904,7 @@
       </p:sp>
       <p:sp>
         <p:nvSpPr>
-          <p:cNvPr id="44" name="Rounded Rectangle 43">
+          <p:cNvPr id="41" name="Rounded Rectangle 40">
             <a:hlinkClick action="ppaction://hlinksldjump" r:id="rId2"/>
           </p:cNvPr>
           <p:cNvSpPr/>
@@ -16265,7 +15960,7 @@
       </p:sp>
       <p:sp>
         <p:nvSpPr>
-          <p:cNvPr id="45" name="Rounded Rectangle 44">
+          <p:cNvPr id="42" name="Rounded Rectangle 41">
             <a:hlinkClick action="ppaction://hlinksldjump" r:id="rId8"/>
           </p:cNvPr>
           <p:cNvSpPr/>
@@ -16321,7 +16016,7 @@
       </p:sp>
       <p:sp>
         <p:nvSpPr>
-          <p:cNvPr id="46" name="Rounded Rectangle 45">
+          <p:cNvPr id="43" name="Rounded Rectangle 42">
             <a:hlinkClick action="ppaction://hlinksldjump" r:id="rId6"/>
           </p:cNvPr>
           <p:cNvSpPr/>
@@ -16377,7 +16072,7 @@
       </p:sp>
       <p:sp>
         <p:nvSpPr>
-          <p:cNvPr id="47" name="Rounded Rectangle 46">
+          <p:cNvPr id="44" name="Rounded Rectangle 43">
             <a:hlinkClick r:id="rId11"/>
           </p:cNvPr>
           <p:cNvSpPr/>
@@ -16433,7 +16128,7 @@
       </p:sp>
       <p:sp>
         <p:nvSpPr>
-          <p:cNvPr id="48" name="Rounded Rectangle 47">
+          <p:cNvPr id="45" name="Rounded Rectangle 44">
             <a:hlinkClick r:id="rId12"/>
           </p:cNvPr>
           <p:cNvSpPr/>
@@ -16489,7 +16184,7 @@
       </p:sp>
       <p:sp>
         <p:nvSpPr>
-          <p:cNvPr id="49" name="TextBox 48"/>
+          <p:cNvPr id="46" name="TextBox 45" descr="Validated publication • 2026-09-v1"/>
           <p:cNvSpPr txBox="1"/>
           <p:nvPr/>
         </p:nvSpPr>
@@ -16550,7 +16245,7 @@
       <p:grpSpPr/>
       <p:sp>
         <p:nvSpPr>
-          <p:cNvPr id="2" name="TextBox 1"/>
+          <p:cNvPr id="2" name="TextBox 1" descr="Data Trust &amp; Reconciliation"/>
           <p:cNvSpPr txBox="1"/>
           <p:nvPr/>
         </p:nvSpPr>
@@ -16585,7 +16280,7 @@
       </p:sp>
       <p:sp>
         <p:nvSpPr>
-          <p:cNvPr id="3" name="TextBox 2"/>
+          <p:cNvPr id="3" name="TextBox 2" descr="Confidence in the data path, mapping state and publication integrity"/>
           <p:cNvSpPr txBox="1"/>
           <p:nvPr/>
         </p:nvSpPr>
@@ -16773,7 +16468,7 @@
       </p:sp>
       <p:sp>
         <p:nvSpPr>
-          <p:cNvPr id="7" name="TextBox 6"/>
+          <p:cNvPr id="7" name="TextBox 6" descr="Run 20261005T175406684735Z"/>
           <p:cNvSpPr txBox="1"/>
           <p:nvPr/>
         </p:nvSpPr>
@@ -16801,7 +16496,7 @@
                 </a:solidFill>
                 <a:latin typeface="Arial"/>
               </a:rPr>
-              <a:t>Run 20261005T170737325190Z</a:t>
+              <a:t>Run 20261005T175406684735Z</a:t>
             </a:r>
           </a:p>
         </p:txBody>
@@ -17256,7 +16951,7 @@
       </p:sp>
       <p:sp>
         <p:nvSpPr>
-          <p:cNvPr id="16" name="TextBox 15"/>
+          <p:cNvPr id="16" name="TextBox 15" descr="Every source record is accounted for"/>
           <p:cNvSpPr txBox="1"/>
           <p:nvPr/>
         </p:nvSpPr>
@@ -17336,7 +17031,7 @@
       </p:sp>
       <p:sp>
         <p:nvSpPr>
-          <p:cNvPr id="18" name="TextBox 17"/>
+          <p:cNvPr id="18" name="TextBox 17" descr="291 expected"/>
           <p:cNvSpPr txBox="1"/>
           <p:nvPr/>
         </p:nvSpPr>
@@ -17371,7 +17066,7 @@
       </p:sp>
       <p:sp>
         <p:nvSpPr>
-          <p:cNvPr id="19" name="TextBox 18"/>
+          <p:cNvPr id="19" name="TextBox 18" descr="→"/>
           <p:cNvSpPr txBox="1"/>
           <p:nvPr/>
         </p:nvSpPr>
@@ -17451,7 +17146,7 @@
       </p:sp>
       <p:sp>
         <p:nvSpPr>
-          <p:cNvPr id="21" name="TextBox 20"/>
+          <p:cNvPr id="21" name="TextBox 20" descr="291 received"/>
           <p:cNvSpPr txBox="1"/>
           <p:nvPr/>
         </p:nvSpPr>
@@ -17475,7 +17170,7 @@
             <a:r>
               <a:rPr sz="2000" b="1">
                 <a:solidFill>
-                  <a:srgbClr val="0891B2"/>
+                  <a:srgbClr val="0E7490"/>
                 </a:solidFill>
                 <a:latin typeface="Arial"/>
               </a:rPr>
@@ -17486,7 +17181,7 @@
       </p:sp>
       <p:sp>
         <p:nvSpPr>
-          <p:cNvPr id="22" name="TextBox 21"/>
+          <p:cNvPr id="22" name="TextBox 21" descr="→"/>
           <p:cNvSpPr txBox="1"/>
           <p:nvPr/>
         </p:nvSpPr>
@@ -17566,7 +17261,7 @@
       </p:sp>
       <p:sp>
         <p:nvSpPr>
-          <p:cNvPr id="24" name="TextBox 23"/>
+          <p:cNvPr id="24" name="TextBox 23" descr="281 mapped"/>
           <p:cNvSpPr txBox="1"/>
           <p:nvPr/>
         </p:nvSpPr>
@@ -17601,7 +17296,7 @@
       </p:sp>
       <p:sp>
         <p:nvSpPr>
-          <p:cNvPr id="25" name="TextBox 24"/>
+          <p:cNvPr id="25" name="TextBox 24" descr="→"/>
           <p:cNvSpPr txBox="1"/>
           <p:nvPr/>
         </p:nvSpPr>
@@ -17681,7 +17376,7 @@
       </p:sp>
       <p:sp>
         <p:nvSpPr>
-          <p:cNvPr id="27" name="TextBox 26"/>
+          <p:cNvPr id="27" name="TextBox 26" descr="253 evaluated"/>
           <p:cNvSpPr txBox="1"/>
           <p:nvPr/>
         </p:nvSpPr>
@@ -17705,7 +17400,7 @@
             <a:r>
               <a:rPr sz="2000" b="1">
                 <a:solidFill>
-                  <a:srgbClr val="16A34A"/>
+                  <a:srgbClr val="15803D"/>
                 </a:solidFill>
                 <a:latin typeface="Arial"/>
               </a:rPr>
@@ -17761,7 +17456,7 @@
       </p:sp>
       <p:sp>
         <p:nvSpPr>
-          <p:cNvPr id="29" name="TextBox 28"/>
+          <p:cNvPr id="29" name="TextBox 28" descr="10 unmapped source records"/>
           <p:cNvSpPr txBox="1"/>
           <p:nvPr/>
         </p:nvSpPr>
@@ -17796,7 +17491,7 @@
       </p:sp>
       <p:sp>
         <p:nvSpPr>
-          <p:cNvPr id="30" name="TextBox 29"/>
+          <p:cNvPr id="30" name="TextBox 29" descr="Received = mapped + unmapped source records"/>
           <p:cNvSpPr txBox="1"/>
           <p:nvPr/>
         </p:nvSpPr>
@@ -17876,7 +17571,7 @@
       </p:sp>
       <p:sp>
         <p:nvSpPr>
-          <p:cNvPr id="32" name="TextBox 31"/>
+          <p:cNvPr id="32" name="TextBox 31" descr="28 not tested (mapped source records)"/>
           <p:cNvSpPr txBox="1"/>
           <p:nvPr/>
         </p:nvSpPr>
@@ -17911,7 +17606,7 @@
       </p:sp>
       <p:sp>
         <p:nvSpPr>
-          <p:cNvPr id="33" name="TextBox 32"/>
+          <p:cNvPr id="33" name="TextBox 32" descr="Mapped = evaluated + not tested"/>
           <p:cNvSpPr txBox="1"/>
           <p:nvPr/>
         </p:nvSpPr>
@@ -17946,7 +17641,7 @@
       </p:sp>
       <p:sp>
         <p:nvSpPr>
-          <p:cNvPr id="34" name="TextBox 33"/>
+          <p:cNvPr id="34" name="TextBox 33" descr="Separate assurance-test measure: 1 unmapped assurance test. Source-record counts above use a different grain."/>
           <p:cNvSpPr txBox="1"/>
           <p:nvPr/>
         </p:nvSpPr>
@@ -17981,7 +17676,42 @@
       </p:sp>
       <p:sp>
         <p:nvSpPr>
-          <p:cNvPr id="35" name="Rounded Rectangle 34"/>
+          <p:cNvPr id="35" name="TextBox 34" descr="Intermediate gates: 291 structurally valid; 281 testable. Rejected and not-testable populations are retained explicitly."/>
+          <p:cNvSpPr txBox="1"/>
+          <p:nvPr/>
+        </p:nvSpPr>
+        <p:spPr>
+          <a:xfrm>
+            <a:off x="658368" y="5266944"/>
+            <a:ext cx="10543032" cy="164592"/>
+          </a:xfrm>
+          <a:prstGeom prst="rect">
+            <a:avLst/>
+          </a:prstGeom>
+          <a:noFill/>
+        </p:spPr>
+        <p:txBody>
+          <a:bodyPr wrap="square" lIns="9144" rIns="9144" tIns="9144" bIns="9144" anchor="t">
+            <a:spAutoFit/>
+          </a:bodyPr>
+          <a:lstStyle/>
+          <a:p>
+            <a:pPr algn="l"/>
+            <a:r>
+              <a:rPr sz="900" b="0">
+                <a:solidFill>
+                  <a:srgbClr val="5C6C82"/>
+                </a:solidFill>
+                <a:latin typeface="Arial"/>
+              </a:rPr>
+              <a:t>Intermediate gates: 291 structurally valid; 281 testable. Rejected and not-testable populations are retained explicitly.</a:t>
+            </a:r>
+          </a:p>
+        </p:txBody>
+      </p:sp>
+      <p:sp>
+        <p:nvSpPr>
+          <p:cNvPr id="36" name="Rounded Rectangle 35"/>
           <p:cNvSpPr/>
           <p:nvPr/>
         </p:nvSpPr>
@@ -18026,7 +17756,7 @@
       </p:sp>
       <p:sp>
         <p:nvSpPr>
-          <p:cNvPr id="36" name="TextBox 35"/>
+          <p:cNvPr id="37" name="TextBox 36" descr="Trust boundary"/>
           <p:cNvSpPr txBox="1"/>
           <p:nvPr/>
         </p:nvSpPr>
@@ -18061,7 +17791,7 @@
       </p:sp>
       <p:sp>
         <p:nvSpPr>
-          <p:cNvPr id="37" name="TextBox 36"/>
+          <p:cNvPr id="38" name="TextBox 37" descr="Run IDs, hashes and lineage establish identity. Independent validation and governed population checks establish analytical correctness."/>
           <p:cNvSpPr txBox="1"/>
           <p:nvPr/>
         </p:nvSpPr>
@@ -18096,7 +17826,7 @@
       </p:sp>
       <p:sp>
         <p:nvSpPr>
-          <p:cNvPr id="38" name="Rectangle 37"/>
+          <p:cNvPr id="39" name="Rectangle 38"/>
           <p:cNvSpPr/>
           <p:nvPr/>
         </p:nvSpPr>
@@ -18141,7 +17871,7 @@
       </p:sp>
       <p:sp>
         <p:nvSpPr>
-          <p:cNvPr id="39" name="Rounded Rectangle 38">
+          <p:cNvPr id="40" name="Rounded Rectangle 39">
             <a:hlinkClick action="ppaction://hlinksldjump" r:id="rId5"/>
           </p:cNvPr>
           <p:cNvSpPr/>
@@ -18197,7 +17927,7 @@
       </p:sp>
       <p:sp>
         <p:nvSpPr>
-          <p:cNvPr id="40" name="Rounded Rectangle 39">
+          <p:cNvPr id="41" name="Rounded Rectangle 40">
             <a:hlinkClick action="ppaction://hlinksldjump" r:id="rId2"/>
           </p:cNvPr>
           <p:cNvSpPr/>
@@ -18253,7 +17983,7 @@
       </p:sp>
       <p:sp>
         <p:nvSpPr>
-          <p:cNvPr id="41" name="Rounded Rectangle 40">
+          <p:cNvPr id="42" name="Rounded Rectangle 41">
             <a:hlinkClick action="ppaction://hlinksldjump" r:id="rId8"/>
           </p:cNvPr>
           <p:cNvSpPr/>
@@ -18309,7 +18039,7 @@
       </p:sp>
       <p:sp>
         <p:nvSpPr>
-          <p:cNvPr id="42" name="Rounded Rectangle 41">
+          <p:cNvPr id="43" name="Rounded Rectangle 42">
             <a:hlinkClick action="ppaction://hlinksldjump" r:id="rId7"/>
           </p:cNvPr>
           <p:cNvSpPr/>
@@ -18365,7 +18095,7 @@
       </p:sp>
       <p:sp>
         <p:nvSpPr>
-          <p:cNvPr id="43" name="Rounded Rectangle 42">
+          <p:cNvPr id="44" name="Rounded Rectangle 43">
             <a:hlinkClick r:id="rId11"/>
           </p:cNvPr>
           <p:cNvSpPr/>
@@ -18421,7 +18151,7 @@
       </p:sp>
       <p:sp>
         <p:nvSpPr>
-          <p:cNvPr id="44" name="Rounded Rectangle 43">
+          <p:cNvPr id="45" name="Rounded Rectangle 44">
             <a:hlinkClick r:id="rId12"/>
           </p:cNvPr>
           <p:cNvSpPr/>
@@ -18477,7 +18207,7 @@
       </p:sp>
       <p:sp>
         <p:nvSpPr>
-          <p:cNvPr id="45" name="TextBox 44"/>
+          <p:cNvPr id="46" name="TextBox 45" descr="Validated publication • 2026-09-v1"/>
           <p:cNvSpPr txBox="1"/>
           <p:nvPr/>
         </p:nvSpPr>
@@ -18538,7 +18268,7 @@
       <p:grpSpPr/>
       <p:sp>
         <p:nvSpPr>
-          <p:cNvPr id="2" name="TextBox 1"/>
+          <p:cNvPr id="2" name="TextBox 1" descr="Traceability"/>
           <p:cNvSpPr txBox="1"/>
           <p:nvPr/>
         </p:nvSpPr>
@@ -18573,7 +18303,7 @@
       </p:sp>
       <p:sp>
         <p:nvSpPr>
-          <p:cNvPr id="3" name="TextBox 2"/>
+          <p:cNvPr id="3" name="TextBox 2" descr="How executive claims trace back to governed evidence and current-run artifacts"/>
           <p:cNvSpPr txBox="1"/>
           <p:nvPr/>
         </p:nvSpPr>
@@ -18761,7 +18491,7 @@
       </p:sp>
       <p:sp>
         <p:nvSpPr>
-          <p:cNvPr id="7" name="TextBox 6"/>
+          <p:cNvPr id="7" name="TextBox 6" descr="Run 20261005T175406684735Z"/>
           <p:cNvSpPr txBox="1"/>
           <p:nvPr/>
         </p:nvSpPr>
@@ -18789,7 +18519,7 @@
                 </a:solidFill>
                 <a:latin typeface="Arial"/>
               </a:rPr>
-              <a:t>Run 20261005T170737325190Z</a:t>
+              <a:t>Run 20261005T175406684735Z</a:t>
             </a:r>
           </a:p>
         </p:txBody>
@@ -19244,7 +18974,7 @@
       </p:sp>
       <p:sp>
         <p:nvSpPr>
-          <p:cNvPr id="16" name="TextBox 15"/>
+          <p:cNvPr id="16" name="TextBox 15" descr="Synthetic sources, one governed analytical truth"/>
           <p:cNvSpPr txBox="1"/>
           <p:nvPr/>
         </p:nvSpPr>
@@ -19324,7 +19054,7 @@
       </p:sp>
       <p:sp>
         <p:nvSpPr>
-          <p:cNvPr id="18" name="TextBox 17"/>
+          <p:cNvPr id="18" name="TextBox 17" descr="SQLite / enterprise reference"/>
           <p:cNvSpPr txBox="1"/>
           <p:nvPr/>
         </p:nvSpPr>
@@ -19359,7 +19089,7 @@
       </p:sp>
       <p:sp>
         <p:nvSpPr>
-          <p:cNvPr id="19" name="TextBox 18"/>
+          <p:cNvPr id="19" name="TextBox 18" descr="Enterprise identity, risk/control context and mapping references"/>
           <p:cNvSpPr txBox="1"/>
           <p:nvPr/>
         </p:nvSpPr>
@@ -19439,7 +19169,7 @@
       </p:sp>
       <p:sp>
         <p:nvSpPr>
-          <p:cNvPr id="21" name="TextBox 20"/>
+          <p:cNvPr id="21" name="TextBox 20" descr="JSON / control evidence"/>
           <p:cNvSpPr txBox="1"/>
           <p:nvPr/>
         </p:nvSpPr>
@@ -19474,7 +19204,7 @@
       </p:sp>
       <p:sp>
         <p:nvSpPr>
-          <p:cNvPr id="22" name="TextBox 21"/>
+          <p:cNvPr id="22" name="TextBox 21" descr="Control testing and evidence populations"/>
           <p:cNvSpPr txBox="1"/>
           <p:nvPr/>
         </p:nvSpPr>
@@ -19554,7 +19284,7 @@
       </p:sp>
       <p:sp>
         <p:nvSpPr>
-          <p:cNvPr id="24" name="TextBox 23"/>
+          <p:cNvPr id="24" name="TextBox 23" descr="CSV / findings"/>
           <p:cNvSpPr txBox="1"/>
           <p:nvPr/>
         </p:nvSpPr>
@@ -19589,7 +19319,7 @@
       </p:sp>
       <p:sp>
         <p:nvSpPr>
-          <p:cNvPr id="25" name="TextBox 24"/>
+          <p:cNvPr id="25" name="TextBox 24" descr="Finding status and recurrence history"/>
           <p:cNvSpPr txBox="1"/>
           <p:nvPr/>
         </p:nvSpPr>
@@ -19669,7 +19399,7 @@
       </p:sp>
       <p:sp>
         <p:nvSpPr>
-          <p:cNvPr id="27" name="TextBox 26"/>
+          <p:cNvPr id="27" name="TextBox 26" descr="CSV / management actions"/>
           <p:cNvSpPr txBox="1"/>
           <p:nvPr/>
         </p:nvSpPr>
@@ -19704,7 +19434,7 @@
       </p:sp>
       <p:sp>
         <p:nvSpPr>
-          <p:cNvPr id="28" name="TextBox 27"/>
+          <p:cNvPr id="28" name="TextBox 27" descr="Remediation ownership, target dates and closure"/>
           <p:cNvSpPr txBox="1"/>
           <p:nvPr/>
         </p:nvSpPr>
@@ -19739,7 +19469,7 @@
       </p:sp>
       <p:sp>
         <p:nvSpPr>
-          <p:cNvPr id="29" name="TextBox 28"/>
+          <p:cNvPr id="29" name="TextBox 28" descr="PYTHON-DRIVEN FLOW"/>
           <p:cNvSpPr txBox="1"/>
           <p:nvPr/>
         </p:nvSpPr>
@@ -19774,7 +19504,7 @@
       </p:sp>
       <p:sp>
         <p:nvSpPr>
-          <p:cNvPr id="30" name="TextBox 29"/>
+          <p:cNvPr id="30" name="TextBox 29" descr="Source ingestion → Structural validation → Identity normalization → Population reconciliation"/>
           <p:cNvSpPr txBox="1"/>
           <p:nvPr/>
         </p:nvSpPr>
@@ -19809,7 +19539,7 @@
       </p:sp>
       <p:sp>
         <p:nvSpPr>
-          <p:cNvPr id="31" name="TextBox 30"/>
+          <p:cNvPr id="31" name="TextBox 30" descr="Governed analytics → Independent metric validation → Shared publication → PowerPoint / HTML / Tableau"/>
           <p:cNvSpPr txBox="1"/>
           <p:nvPr/>
         </p:nvSpPr>
@@ -19844,7 +19574,7 @@
       </p:sp>
       <p:sp>
         <p:nvSpPr>
-          <p:cNvPr id="32" name="TextBox 31"/>
+          <p:cNvPr id="32" name="TextBox 31" descr="Executive claim → published metric/table → independent validation → governed input → source/configuration"/>
           <p:cNvSpPr txBox="1"/>
           <p:nvPr/>
         </p:nvSpPr>
@@ -19879,7 +19609,7 @@
       </p:sp>
       <p:sp>
         <p:nvSpPr>
-          <p:cNvPr id="33" name="TextBox 32"/>
+          <p:cNvPr id="33" name="TextBox 32" descr="Grain: one test per test ID / period; findings and actions retain their grains."/>
           <p:cNvSpPr txBox="1"/>
           <p:nvPr/>
         </p:nvSpPr>
@@ -19914,7 +19644,7 @@
       </p:sp>
       <p:sp>
         <p:nvSpPr>
-          <p:cNvPr id="34" name="TextBox 33"/>
+          <p:cNvPr id="34" name="TextBox 33" descr="Run identity and hashes establish traceability; metric-contract and scenario checks establish analytical correctness."/>
           <p:cNvSpPr txBox="1"/>
           <p:nvPr/>
         </p:nvSpPr>
@@ -20330,7 +20060,7 @@
       </p:sp>
       <p:sp>
         <p:nvSpPr>
-          <p:cNvPr id="42" name="TextBox 41"/>
+          <p:cNvPr id="42" name="TextBox 41" descr="Validated publication • 2026-09-v1"/>
           <p:cNvSpPr txBox="1"/>
           <p:nvPr/>
         </p:nvSpPr>
@@ -20391,7 +20121,7 @@
       <p:grpSpPr/>
       <p:sp>
         <p:nvSpPr>
-          <p:cNvPr id="2" name="TextBox 1"/>
+          <p:cNvPr id="2" name="TextBox 1" descr="Interactive Analytics"/>
           <p:cNvSpPr txBox="1"/>
           <p:nvPr/>
         </p:nvSpPr>
@@ -20426,7 +20156,7 @@
       </p:sp>
       <p:sp>
         <p:nvSpPr>
-          <p:cNvPr id="3" name="TextBox 2"/>
+          <p:cNvPr id="3" name="TextBox 2" descr="Native PowerPoint navigation into the deeper HTML and Tableau analytical channels"/>
           <p:cNvSpPr txBox="1"/>
           <p:nvPr/>
         </p:nvSpPr>
@@ -20614,7 +20344,7 @@
       </p:sp>
       <p:sp>
         <p:nvSpPr>
-          <p:cNvPr id="7" name="TextBox 6"/>
+          <p:cNvPr id="7" name="TextBox 6" descr="Run 20261005T175406684735Z"/>
           <p:cNvSpPr txBox="1"/>
           <p:nvPr/>
         </p:nvSpPr>
@@ -20642,7 +20372,7 @@
                 </a:solidFill>
                 <a:latin typeface="Arial"/>
               </a:rPr>
-              <a:t>Run 20261005T170737325190Z</a:t>
+              <a:t>Run 20261005T175406684735Z</a:t>
             </a:r>
           </a:p>
         </p:txBody>
@@ -21097,7 +20827,7 @@
       </p:sp>
       <p:sp>
         <p:nvSpPr>
-          <p:cNvPr id="16" name="TextBox 15"/>
+          <p:cNvPr id="16" name="TextBox 15" descr="CHOOSE YOUR DRILL-DOWN"/>
           <p:cNvSpPr txBox="1"/>
           <p:nvPr/>
         </p:nvSpPr>
@@ -21132,7 +20862,7 @@
       </p:sp>
       <p:sp>
         <p:nvSpPr>
-          <p:cNvPr id="17" name="TextBox 16"/>
+          <p:cNvPr id="17" name="TextBox 16" descr="Use PowerPoint as the executive navigation layer"/>
           <p:cNvSpPr txBox="1"/>
           <p:nvPr/>
         </p:nvSpPr>
@@ -21167,7 +20897,7 @@
       </p:sp>
       <p:sp>
         <p:nvSpPr>
-          <p:cNvPr id="18" name="TextBox 17"/>
+          <p:cNvPr id="18" name="TextBox 17" descr="Click a tile to move within the deck, or open the richer browser/Tableau channels for filtering and record-level exploration."/>
           <p:cNvSpPr txBox="1"/>
           <p:nvPr/>
         </p:nvSpPr>
@@ -21303,7 +21033,7 @@
       </p:sp>
       <p:sp>
         <p:nvSpPr>
-          <p:cNvPr id="21" name="TextBox 20"/>
+          <p:cNvPr id="21" name="TextBox 20" descr="Evidence Quality"/>
           <p:cNvSpPr txBox="1"/>
           <p:nvPr/>
         </p:nvSpPr>
@@ -21338,7 +21068,7 @@
       </p:sp>
       <p:sp>
         <p:nvSpPr>
-          <p:cNvPr id="22" name="TextBox 21"/>
+          <p:cNvPr id="22" name="TextBox 21" descr="Evidence sufficiency, freshness and confidence"/>
           <p:cNvSpPr txBox="1"/>
           <p:nvPr/>
         </p:nvSpPr>
@@ -21433,11 +21163,11 @@
             <a:avLst/>
           </a:prstGeom>
           <a:solidFill>
-            <a:srgbClr val="DC2626"/>
+            <a:srgbClr val="B91C1C"/>
           </a:solidFill>
           <a:ln>
             <a:solidFill>
-              <a:srgbClr val="DC2626"/>
+              <a:srgbClr val="B91C1C"/>
             </a:solidFill>
           </a:ln>
         </p:spPr>
@@ -21474,7 +21204,7 @@
       </p:sp>
       <p:sp>
         <p:nvSpPr>
-          <p:cNvPr id="25" name="TextBox 24"/>
+          <p:cNvPr id="25" name="TextBox 24" descr="Risk &amp; Control"/>
           <p:cNvSpPr txBox="1"/>
           <p:nvPr/>
         </p:nvSpPr>
@@ -21509,7 +21239,7 @@
       </p:sp>
       <p:sp>
         <p:nvSpPr>
-          <p:cNvPr id="26" name="TextBox 25"/>
+          <p:cNvPr id="26" name="TextBox 25" descr="Domain pressure and residual-risk visibility"/>
           <p:cNvSpPr txBox="1"/>
           <p:nvPr/>
         </p:nvSpPr>
@@ -21604,11 +21334,11 @@
             <a:avLst/>
           </a:prstGeom>
           <a:solidFill>
-            <a:srgbClr val="D97706"/>
+            <a:srgbClr val="B45309"/>
           </a:solidFill>
           <a:ln>
             <a:solidFill>
-              <a:srgbClr val="D97706"/>
+              <a:srgbClr val="B45309"/>
             </a:solidFill>
           </a:ln>
         </p:spPr>
@@ -21645,7 +21375,7 @@
       </p:sp>
       <p:sp>
         <p:nvSpPr>
-          <p:cNvPr id="29" name="TextBox 28"/>
+          <p:cNvPr id="29" name="TextBox 28" descr="Findings"/>
           <p:cNvSpPr txBox="1"/>
           <p:nvPr/>
         </p:nvSpPr>
@@ -21680,7 +21410,7 @@
       </p:sp>
       <p:sp>
         <p:nvSpPr>
-          <p:cNvPr id="30" name="TextBox 29"/>
+          <p:cNvPr id="30" name="TextBox 29" descr="Open, repeat and overdue remediation signals"/>
           <p:cNvSpPr txBox="1"/>
           <p:nvPr/>
         </p:nvSpPr>
@@ -21775,11 +21505,11 @@
             <a:avLst/>
           </a:prstGeom>
           <a:solidFill>
-            <a:srgbClr val="16A34A"/>
+            <a:srgbClr val="15803D"/>
           </a:solidFill>
           <a:ln>
             <a:solidFill>
-              <a:srgbClr val="16A34A"/>
+              <a:srgbClr val="15803D"/>
             </a:solidFill>
           </a:ln>
         </p:spPr>
@@ -21816,7 +21546,7 @@
       </p:sp>
       <p:sp>
         <p:nvSpPr>
-          <p:cNvPr id="33" name="TextBox 32"/>
+          <p:cNvPr id="33" name="TextBox 32" descr="Data Trust"/>
           <p:cNvSpPr txBox="1"/>
           <p:nvPr/>
         </p:nvSpPr>
@@ -21851,7 +21581,7 @@
       </p:sp>
       <p:sp>
         <p:nvSpPr>
-          <p:cNvPr id="34" name="TextBox 33"/>
+          <p:cNvPr id="34" name="TextBox 33" descr="Lineage, validation and current-run identity"/>
           <p:cNvSpPr txBox="1"/>
           <p:nvPr/>
         </p:nvSpPr>
@@ -21987,7 +21717,7 @@
       </p:sp>
       <p:sp>
         <p:nvSpPr>
-          <p:cNvPr id="37" name="TextBox 36"/>
+          <p:cNvPr id="37" name="TextBox 36" descr="Traceability"/>
           <p:cNvSpPr txBox="1"/>
           <p:nvPr/>
         </p:nvSpPr>
@@ -22022,7 +21752,7 @@
       </p:sp>
       <p:sp>
         <p:nvSpPr>
-          <p:cNvPr id="38" name="TextBox 37"/>
+          <p:cNvPr id="38" name="TextBox 37" descr="Claim-to-source evidence chain"/>
           <p:cNvSpPr txBox="1"/>
           <p:nvPr/>
         </p:nvSpPr>
@@ -22158,7 +21888,7 @@
       </p:sp>
       <p:sp>
         <p:nvSpPr>
-          <p:cNvPr id="41" name="TextBox 40"/>
+          <p:cNvPr id="41" name="TextBox 40" descr="Methods"/>
           <p:cNvSpPr txBox="1"/>
           <p:nvPr/>
         </p:nvSpPr>
@@ -22193,7 +21923,7 @@
       </p:sp>
       <p:sp>
         <p:nvSpPr>
-          <p:cNvPr id="42" name="TextBox 41"/>
+          <p:cNvPr id="42" name="TextBox 41" descr="Scope, limitations and next steps"/>
           <p:cNvSpPr txBox="1"/>
           <p:nvPr/>
         </p:nvSpPr>
@@ -22721,7 +22451,7 @@
       </p:sp>
       <p:sp>
         <p:nvSpPr>
-          <p:cNvPr id="52" name="TextBox 51"/>
+          <p:cNvPr id="52" name="TextBox 51" descr="Validated publication • 2026-09-v1"/>
           <p:cNvSpPr txBox="1"/>
           <p:nvPr/>
         </p:nvSpPr>
@@ -22782,7 +22512,7 @@
       <p:grpSpPr/>
       <p:sp>
         <p:nvSpPr>
-          <p:cNvPr id="2" name="TextBox 1"/>
+          <p:cNvPr id="2" name="TextBox 1" descr="Methodology, Limitations &amp; Next Steps"/>
           <p:cNvSpPr txBox="1"/>
           <p:nvPr/>
         </p:nvSpPr>
@@ -22817,7 +22547,7 @@
       </p:sp>
       <p:sp>
         <p:nvSpPr>
-          <p:cNvPr id="3" name="TextBox 2"/>
+          <p:cNvPr id="3" name="TextBox 2" descr="Scope, validation boundaries, limitations and recommended next actions"/>
           <p:cNvSpPr txBox="1"/>
           <p:nvPr/>
         </p:nvSpPr>
@@ -23005,7 +22735,7 @@
       </p:sp>
       <p:sp>
         <p:nvSpPr>
-          <p:cNvPr id="7" name="TextBox 6"/>
+          <p:cNvPr id="7" name="TextBox 6" descr="Run 20261005T175406684735Z"/>
           <p:cNvSpPr txBox="1"/>
           <p:nvPr/>
         </p:nvSpPr>
@@ -23033,7 +22763,7 @@
                 </a:solidFill>
                 <a:latin typeface="Arial"/>
               </a:rPr>
-              <a:t>Run 20261005T170737325190Z</a:t>
+              <a:t>Run 20261005T175406684735Z</a:t>
             </a:r>
           </a:p>
         </p:txBody>
@@ -23488,7 +23218,7 @@
       </p:sp>
       <p:sp>
         <p:nvSpPr>
-          <p:cNvPr id="16" name="TextBox 15"/>
+          <p:cNvPr id="16" name="TextBox 15" descr="METHOD &amp; ACCEPTANCE"/>
           <p:cNvSpPr txBox="1"/>
           <p:nvPr/>
         </p:nvSpPr>
@@ -23613,7 +23343,7 @@
       </p:sp>
       <p:sp>
         <p:nvSpPr>
-          <p:cNvPr id="19" name="TextBox 18"/>
+          <p:cNvPr id="19" name="TextBox 18" descr="20261005T175406684735Z"/>
           <p:cNvSpPr txBox="1"/>
           <p:nvPr/>
         </p:nvSpPr>
@@ -23641,21 +23371,21 @@
                 </a:solidFill>
                 <a:latin typeface="Arial"/>
               </a:rPr>
-              <a:t>20261005T170737325190Z</a:t>
-            </a:r>
-          </a:p>
-        </p:txBody>
-      </p:sp>
-      <p:sp>
-        <p:nvSpPr>
-          <p:cNvPr id="20" name="TextBox 19"/>
+              <a:t>20261005T175406684735Z</a:t>
+            </a:r>
+          </a:p>
+        </p:txBody>
+      </p:sp>
+      <p:sp>
+        <p:nvSpPr>
+          <p:cNvPr id="20" name="TextBox 19" descr="Publication run"/>
           <p:cNvSpPr txBox="1"/>
           <p:nvPr/>
         </p:nvSpPr>
         <p:spPr>
           <a:xfrm>
             <a:off x="822959" y="2542032"/>
-            <a:ext cx="1947672" cy="210312"/>
+            <a:ext cx="1947672" cy="310896"/>
           </a:xfrm>
           <a:prstGeom prst="rect">
             <a:avLst/>
@@ -23670,7 +23400,7 @@
           <a:p>
             <a:pPr algn="l"/>
             <a:r>
-              <a:rPr sz="850" b="0">
+              <a:rPr sz="1000" b="0">
                 <a:solidFill>
                   <a:srgbClr val="5C6C82"/>
                 </a:solidFill>
@@ -23683,42 +23413,7 @@
       </p:sp>
       <p:sp>
         <p:nvSpPr>
-          <p:cNvPr id="21" name="TextBox 20"/>
-          <p:cNvSpPr txBox="1"/>
-          <p:nvPr/>
-        </p:nvSpPr>
-        <p:spPr>
-          <a:xfrm>
-            <a:off x="2240280" y="2679192"/>
-            <a:ext cx="457200" cy="155448"/>
-          </a:xfrm>
-          <a:prstGeom prst="rect">
-            <a:avLst/>
-          </a:prstGeom>
-          <a:noFill/>
-        </p:spPr>
-        <p:txBody>
-          <a:bodyPr wrap="square" lIns="9144" rIns="9144" tIns="9144" bIns="9144" anchor="t">
-            <a:spAutoFit/>
-          </a:bodyPr>
-          <a:lstStyle/>
-          <a:p>
-            <a:pPr algn="r"/>
-            <a:r>
-              <a:rPr sz="650" b="1">
-                <a:solidFill>
-                  <a:srgbClr val="2463EB"/>
-                </a:solidFill>
-                <a:latin typeface="Arial"/>
-              </a:rPr>
-              <a:t>VIEW ›</a:t>
-            </a:r>
-          </a:p>
-        </p:txBody>
-      </p:sp>
-      <p:sp>
-        <p:nvSpPr>
-          <p:cNvPr id="22" name="Rounded Rectangle 21"/>
+          <p:cNvPr id="21" name="Rounded Rectangle 20"/>
           <p:cNvSpPr/>
           <p:nvPr/>
         </p:nvSpPr>
@@ -23763,7 +23458,7 @@
       </p:sp>
       <p:sp>
         <p:nvSpPr>
-          <p:cNvPr id="23" name="Rounded Rectangle 22"/>
+          <p:cNvPr id="22" name="Rounded Rectangle 21"/>
           <p:cNvSpPr/>
           <p:nvPr/>
         </p:nvSpPr>
@@ -23808,7 +23503,7 @@
       </p:sp>
       <p:sp>
         <p:nvSpPr>
-          <p:cNvPr id="24" name="TextBox 23"/>
+          <p:cNvPr id="23" name="TextBox 22" descr="2026-09-v1"/>
           <p:cNvSpPr txBox="1"/>
           <p:nvPr/>
         </p:nvSpPr>
@@ -23843,14 +23538,14 @@
       </p:sp>
       <p:sp>
         <p:nvSpPr>
-          <p:cNvPr id="25" name="TextBox 24"/>
+          <p:cNvPr id="24" name="TextBox 23" descr="Methodology"/>
           <p:cNvSpPr txBox="1"/>
           <p:nvPr/>
         </p:nvSpPr>
         <p:spPr>
           <a:xfrm>
             <a:off x="3310128" y="2542032"/>
-            <a:ext cx="1947672" cy="210312"/>
+            <a:ext cx="1947672" cy="310896"/>
           </a:xfrm>
           <a:prstGeom prst="rect">
             <a:avLst/>
@@ -23865,7 +23560,7 @@
           <a:p>
             <a:pPr algn="l"/>
             <a:r>
-              <a:rPr sz="850" b="0">
+              <a:rPr sz="1000" b="0">
                 <a:solidFill>
                   <a:srgbClr val="5C6C82"/>
                 </a:solidFill>
@@ -23878,42 +23573,7 @@
       </p:sp>
       <p:sp>
         <p:nvSpPr>
-          <p:cNvPr id="26" name="TextBox 25"/>
-          <p:cNvSpPr txBox="1"/>
-          <p:nvPr/>
-        </p:nvSpPr>
-        <p:spPr>
-          <a:xfrm>
-            <a:off x="4727448" y="2679192"/>
-            <a:ext cx="457200" cy="155448"/>
-          </a:xfrm>
-          <a:prstGeom prst="rect">
-            <a:avLst/>
-          </a:prstGeom>
-          <a:noFill/>
-        </p:spPr>
-        <p:txBody>
-          <a:bodyPr wrap="square" lIns="9144" rIns="9144" tIns="9144" bIns="9144" anchor="t">
-            <a:spAutoFit/>
-          </a:bodyPr>
-          <a:lstStyle/>
-          <a:p>
-            <a:pPr algn="r"/>
-            <a:r>
-              <a:rPr sz="650" b="1">
-                <a:solidFill>
-                  <a:srgbClr val="7E22CE"/>
-                </a:solidFill>
-                <a:latin typeface="Arial"/>
-              </a:rPr>
-              <a:t>VIEW ›</a:t>
-            </a:r>
-          </a:p>
-        </p:txBody>
-      </p:sp>
-      <p:sp>
-        <p:nvSpPr>
-          <p:cNvPr id="27" name="Rounded Rectangle 26"/>
+          <p:cNvPr id="25" name="Rounded Rectangle 24"/>
           <p:cNvSpPr/>
           <p:nvPr/>
         </p:nvSpPr>
@@ -23958,7 +23618,7 @@
       </p:sp>
       <p:sp>
         <p:nvSpPr>
-          <p:cNvPr id="28" name="Rounded Rectangle 27"/>
+          <p:cNvPr id="26" name="Rounded Rectangle 25"/>
           <p:cNvSpPr/>
           <p:nvPr/>
         </p:nvSpPr>
@@ -23971,11 +23631,11 @@
             <a:avLst/>
           </a:prstGeom>
           <a:solidFill>
-            <a:srgbClr val="16A34A"/>
+            <a:srgbClr val="15803D"/>
           </a:solidFill>
           <a:ln>
             <a:solidFill>
-              <a:srgbClr val="16A34A"/>
+              <a:srgbClr val="15803D"/>
             </a:solidFill>
           </a:ln>
         </p:spPr>
@@ -24003,7 +23663,7 @@
       </p:sp>
       <p:sp>
         <p:nvSpPr>
-          <p:cNvPr id="29" name="TextBox 28"/>
+          <p:cNvPr id="27" name="TextBox 26" descr="PASS"/>
           <p:cNvSpPr txBox="1"/>
           <p:nvPr/>
         </p:nvSpPr>
@@ -24038,14 +23698,14 @@
       </p:sp>
       <p:sp>
         <p:nvSpPr>
-          <p:cNvPr id="30" name="TextBox 29"/>
+          <p:cNvPr id="28" name="TextBox 27" descr="Metric validation"/>
           <p:cNvSpPr txBox="1"/>
           <p:nvPr/>
         </p:nvSpPr>
         <p:spPr>
           <a:xfrm>
             <a:off x="822959" y="3639312"/>
-            <a:ext cx="1947672" cy="210312"/>
+            <a:ext cx="1947672" cy="310896"/>
           </a:xfrm>
           <a:prstGeom prst="rect">
             <a:avLst/>
@@ -24060,7 +23720,7 @@
           <a:p>
             <a:pPr algn="l"/>
             <a:r>
-              <a:rPr sz="850" b="0">
+              <a:rPr sz="1000" b="0">
                 <a:solidFill>
                   <a:srgbClr val="5C6C82"/>
                 </a:solidFill>
@@ -24073,42 +23733,7 @@
       </p:sp>
       <p:sp>
         <p:nvSpPr>
-          <p:cNvPr id="31" name="TextBox 30"/>
-          <p:cNvSpPr txBox="1"/>
-          <p:nvPr/>
-        </p:nvSpPr>
-        <p:spPr>
-          <a:xfrm>
-            <a:off x="2240280" y="3776472"/>
-            <a:ext cx="457200" cy="155448"/>
-          </a:xfrm>
-          <a:prstGeom prst="rect">
-            <a:avLst/>
-          </a:prstGeom>
-          <a:noFill/>
-        </p:spPr>
-        <p:txBody>
-          <a:bodyPr wrap="square" lIns="9144" rIns="9144" tIns="9144" bIns="9144" anchor="t">
-            <a:spAutoFit/>
-          </a:bodyPr>
-          <a:lstStyle/>
-          <a:p>
-            <a:pPr algn="r"/>
-            <a:r>
-              <a:rPr sz="650" b="1">
-                <a:solidFill>
-                  <a:srgbClr val="16A34A"/>
-                </a:solidFill>
-                <a:latin typeface="Arial"/>
-              </a:rPr>
-              <a:t>VIEW ›</a:t>
-            </a:r>
-          </a:p>
-        </p:txBody>
-      </p:sp>
-      <p:sp>
-        <p:nvSpPr>
-          <p:cNvPr id="32" name="Rounded Rectangle 31"/>
+          <p:cNvPr id="29" name="Rounded Rectangle 28"/>
           <p:cNvSpPr/>
           <p:nvPr/>
         </p:nvSpPr>
@@ -24153,7 +23778,7 @@
       </p:sp>
       <p:sp>
         <p:nvSpPr>
-          <p:cNvPr id="33" name="Rounded Rectangle 32"/>
+          <p:cNvPr id="30" name="Rounded Rectangle 29"/>
           <p:cNvSpPr/>
           <p:nvPr/>
         </p:nvSpPr>
@@ -24166,11 +23791,11 @@
             <a:avLst/>
           </a:prstGeom>
           <a:solidFill>
-            <a:srgbClr val="16A34A"/>
+            <a:srgbClr val="15803D"/>
           </a:solidFill>
           <a:ln>
             <a:solidFill>
-              <a:srgbClr val="16A34A"/>
+              <a:srgbClr val="15803D"/>
             </a:solidFill>
           </a:ln>
         </p:spPr>
@@ -24198,7 +23823,7 @@
       </p:sp>
       <p:sp>
         <p:nvSpPr>
-          <p:cNvPr id="34" name="TextBox 33"/>
+          <p:cNvPr id="31" name="TextBox 30" descr="PASS"/>
           <p:cNvSpPr txBox="1"/>
           <p:nvPr/>
         </p:nvSpPr>
@@ -24233,14 +23858,14 @@
       </p:sp>
       <p:sp>
         <p:nvSpPr>
-          <p:cNvPr id="35" name="TextBox 34"/>
+          <p:cNvPr id="32" name="TextBox 31" descr="Publication validation"/>
           <p:cNvSpPr txBox="1"/>
           <p:nvPr/>
         </p:nvSpPr>
         <p:spPr>
           <a:xfrm>
             <a:off x="3310128" y="3639312"/>
-            <a:ext cx="1947672" cy="210312"/>
+            <a:ext cx="1947672" cy="310896"/>
           </a:xfrm>
           <a:prstGeom prst="rect">
             <a:avLst/>
@@ -24255,7 +23880,7 @@
           <a:p>
             <a:pPr algn="l"/>
             <a:r>
-              <a:rPr sz="850" b="0">
+              <a:rPr sz="1000" b="0">
                 <a:solidFill>
                   <a:srgbClr val="5C6C82"/>
                 </a:solidFill>
@@ -24268,42 +23893,7 @@
       </p:sp>
       <p:sp>
         <p:nvSpPr>
-          <p:cNvPr id="36" name="TextBox 35"/>
-          <p:cNvSpPr txBox="1"/>
-          <p:nvPr/>
-        </p:nvSpPr>
-        <p:spPr>
-          <a:xfrm>
-            <a:off x="4727448" y="3776472"/>
-            <a:ext cx="457200" cy="155448"/>
-          </a:xfrm>
-          <a:prstGeom prst="rect">
-            <a:avLst/>
-          </a:prstGeom>
-          <a:noFill/>
-        </p:spPr>
-        <p:txBody>
-          <a:bodyPr wrap="square" lIns="9144" rIns="9144" tIns="9144" bIns="9144" anchor="t">
-            <a:spAutoFit/>
-          </a:bodyPr>
-          <a:lstStyle/>
-          <a:p>
-            <a:pPr algn="r"/>
-            <a:r>
-              <a:rPr sz="650" b="1">
-                <a:solidFill>
-                  <a:srgbClr val="16A34A"/>
-                </a:solidFill>
-                <a:latin typeface="Arial"/>
-              </a:rPr>
-              <a:t>VIEW ›</a:t>
-            </a:r>
-          </a:p>
-        </p:txBody>
-      </p:sp>
-      <p:sp>
-        <p:nvSpPr>
-          <p:cNvPr id="37" name="Rounded Rectangle 36"/>
+          <p:cNvPr id="33" name="Rounded Rectangle 32"/>
           <p:cNvSpPr/>
           <p:nvPr/>
         </p:nvSpPr>
@@ -24348,7 +23938,7 @@
       </p:sp>
       <p:sp>
         <p:nvSpPr>
-          <p:cNvPr id="38" name="TextBox 37"/>
+          <p:cNvPr id="34" name="TextBox 33" descr="Priority 1 — Restore decision confidence"/>
           <p:cNvSpPr txBox="1"/>
           <p:nvPr/>
         </p:nvSpPr>
@@ -24383,7 +23973,7 @@
       </p:sp>
       <p:sp>
         <p:nvSpPr>
-          <p:cNvPr id="39" name="TextBox 38"/>
+          <p:cNvPr id="35" name="TextBox 34" descr="Refresh the 2 stale-evidence cases and resolve the 1 evidence-not-evaluable case."/>
           <p:cNvSpPr txBox="1"/>
           <p:nvPr/>
         </p:nvSpPr>
@@ -24418,7 +24008,7 @@
       </p:sp>
       <p:sp>
         <p:nvSpPr>
-          <p:cNvPr id="40" name="Rounded Rectangle 39"/>
+          <p:cNvPr id="36" name="Rounded Rectangle 35"/>
           <p:cNvSpPr/>
           <p:nvPr/>
         </p:nvSpPr>
@@ -24463,7 +24053,7 @@
       </p:sp>
       <p:sp>
         <p:nvSpPr>
-          <p:cNvPr id="41" name="TextBox 40"/>
+          <p:cNvPr id="37" name="TextBox 36" descr="Priority 2 — Close risk uncertainty"/>
           <p:cNvSpPr txBox="1"/>
           <p:nvPr/>
         </p:nvSpPr>
@@ -24498,7 +24088,7 @@
       </p:sp>
       <p:sp>
         <p:nvSpPr>
-          <p:cNvPr id="42" name="TextBox 41"/>
+          <p:cNvPr id="38" name="TextBox 37" descr="Resolve the 4 residual-risk conclusions that remain not evaluable, starting with areas already carrying high/critical risk."/>
           <p:cNvSpPr txBox="1"/>
           <p:nvPr/>
         </p:nvSpPr>
@@ -24533,7 +24123,7 @@
       </p:sp>
       <p:sp>
         <p:nvSpPr>
-          <p:cNvPr id="43" name="Rounded Rectangle 42"/>
+          <p:cNvPr id="39" name="Rounded Rectangle 38"/>
           <p:cNvSpPr/>
           <p:nvPr/>
         </p:nvSpPr>
@@ -24578,7 +24168,7 @@
       </p:sp>
       <p:sp>
         <p:nvSpPr>
-          <p:cNvPr id="44" name="TextBox 43"/>
+          <p:cNvPr id="40" name="TextBox 39" descr="Priority 3 — Close operational exceptions"/>
           <p:cNvSpPr txBox="1"/>
           <p:nvPr/>
         </p:nvSpPr>
@@ -24613,7 +24203,7 @@
       </p:sp>
       <p:sp>
         <p:nvSpPr>
-          <p:cNvPr id="45" name="TextBox 44"/>
+          <p:cNvPr id="41" name="TextBox 40" descr="Address the 1 overdue management action and monitor the 1 unmapped assurance test explicitly."/>
           <p:cNvSpPr txBox="1"/>
           <p:nvPr/>
         </p:nvSpPr>
@@ -24648,7 +24238,7 @@
       </p:sp>
       <p:sp>
         <p:nvSpPr>
-          <p:cNvPr id="46" name="TextBox 45"/>
+          <p:cNvPr id="42" name="TextBox 41" descr="Governed publication inputs preserve KPI definitions. Native slide navigation links to HTML/Tableau for interactive filtering."/>
           <p:cNvSpPr txBox="1"/>
           <p:nvPr/>
         </p:nvSpPr>
@@ -24683,7 +24273,7 @@
       </p:sp>
       <p:sp>
         <p:nvSpPr>
-          <p:cNvPr id="47" name="TextBox 46"/>
+          <p:cNvPr id="43" name="TextBox 42" descr="Illustrative synthetic enterprise-assurance dataset and methodology; not Experian internal data or methodology."/>
           <p:cNvSpPr txBox="1"/>
           <p:nvPr/>
         </p:nvSpPr>
@@ -24718,7 +24308,7 @@
       </p:sp>
       <p:sp>
         <p:nvSpPr>
-          <p:cNvPr id="48" name="Rounded Rectangle 47">
+          <p:cNvPr id="44" name="Rounded Rectangle 43">
             <a:hlinkClick action="ppaction://hlinksldjump" r:id="rId2"/>
           </p:cNvPr>
           <p:cNvSpPr/>
@@ -24774,7 +24364,7 @@
       </p:sp>
       <p:sp>
         <p:nvSpPr>
-          <p:cNvPr id="49" name="Rounded Rectangle 48">
+          <p:cNvPr id="45" name="Rounded Rectangle 44">
             <a:hlinkClick action="ppaction://hlinksldjump" r:id="rId8"/>
           </p:cNvPr>
           <p:cNvSpPr/>
@@ -24830,7 +24420,7 @@
       </p:sp>
       <p:sp>
         <p:nvSpPr>
-          <p:cNvPr id="50" name="Rectangle 49"/>
+          <p:cNvPr id="46" name="Rectangle 45"/>
           <p:cNvSpPr/>
           <p:nvPr/>
         </p:nvSpPr>
@@ -24875,7 +24465,7 @@
       </p:sp>
       <p:sp>
         <p:nvSpPr>
-          <p:cNvPr id="51" name="Rounded Rectangle 50">
+          <p:cNvPr id="47" name="Rounded Rectangle 46">
             <a:hlinkClick action="ppaction://hlinksldjump" r:id="rId8"/>
           </p:cNvPr>
           <p:cNvSpPr/>
@@ -24931,7 +24521,7 @@
       </p:sp>
       <p:sp>
         <p:nvSpPr>
-          <p:cNvPr id="52" name="Rounded Rectangle 51">
+          <p:cNvPr id="48" name="Rounded Rectangle 47">
             <a:hlinkClick action="ppaction://hlinksldjump" r:id="rId2"/>
           </p:cNvPr>
           <p:cNvSpPr/>
@@ -24987,7 +24577,7 @@
       </p:sp>
       <p:sp>
         <p:nvSpPr>
-          <p:cNvPr id="53" name="Rounded Rectangle 52">
+          <p:cNvPr id="49" name="Rounded Rectangle 48">
             <a:hlinkClick action="ppaction://hlinksldjump" r:id="rId8"/>
           </p:cNvPr>
           <p:cNvSpPr/>
@@ -25043,7 +24633,7 @@
       </p:sp>
       <p:sp>
         <p:nvSpPr>
-          <p:cNvPr id="54" name="Rounded Rectangle 53">
+          <p:cNvPr id="50" name="Rounded Rectangle 49">
             <a:hlinkClick action="ppaction://hlinksldjump" r:id="rId9"/>
           </p:cNvPr>
           <p:cNvSpPr/>
@@ -25099,7 +24689,7 @@
       </p:sp>
       <p:sp>
         <p:nvSpPr>
-          <p:cNvPr id="55" name="Rounded Rectangle 54">
+          <p:cNvPr id="51" name="Rounded Rectangle 50">
             <a:hlinkClick r:id="rId11"/>
           </p:cNvPr>
           <p:cNvSpPr/>
@@ -25155,7 +24745,7 @@
       </p:sp>
       <p:sp>
         <p:nvSpPr>
-          <p:cNvPr id="56" name="Rounded Rectangle 55">
+          <p:cNvPr id="52" name="Rounded Rectangle 51">
             <a:hlinkClick r:id="rId12"/>
           </p:cNvPr>
           <p:cNvSpPr/>
@@ -25211,7 +24801,7 @@
       </p:sp>
       <p:sp>
         <p:nvSpPr>
-          <p:cNvPr id="57" name="TextBox 56"/>
+          <p:cNvPr id="53" name="TextBox 52" descr="Validated publication • 2026-09-v1"/>
           <p:cNvSpPr txBox="1"/>
           <p:nvPr/>
         </p:nvSpPr>

</xml_diff>

<commit_message>
docs: refresh canonical reviewer provenance after history cleanup
</commit_message>
<xml_diff>
--- a/review/presentation/assurance_executive_report.pptx
+++ b/review/presentation/assurance_executive_report.pptx
@@ -5478,7 +5478,7 @@
       </p:sp>
       <p:sp>
         <p:nvSpPr>
-          <p:cNvPr id="7" name="TextBox 6" descr="Run 20261005T175406684735Z"/>
+          <p:cNvPr id="7" name="TextBox 6" descr="Run 20261006T015512364859Z"/>
           <p:cNvSpPr txBox="1"/>
           <p:nvPr/>
         </p:nvSpPr>
@@ -5506,7 +5506,7 @@
                 </a:solidFill>
                 <a:latin typeface="Arial"/>
               </a:rPr>
-              <a:t>Run 20261005T175406684735Z</a:t>
+              <a:t>Run 20261006T015512364859Z</a:t>
             </a:r>
           </a:p>
         </p:txBody>
@@ -8245,7 +8245,7 @@
       </p:sp>
       <p:sp>
         <p:nvSpPr>
-          <p:cNvPr id="7" name="TextBox 6" descr="Run 20261005T175406684735Z"/>
+          <p:cNvPr id="7" name="TextBox 6" descr="Run 20261006T015512364859Z"/>
           <p:cNvSpPr txBox="1"/>
           <p:nvPr/>
         </p:nvSpPr>
@@ -8273,7 +8273,7 @@
                 </a:solidFill>
                 <a:latin typeface="Arial"/>
               </a:rPr>
-              <a:t>Run 20261005T175406684735Z</a:t>
+              <a:t>Run 20261006T015512364859Z</a:t>
             </a:r>
           </a:p>
         </p:txBody>
@@ -10852,7 +10852,7 @@
       </p:sp>
       <p:sp>
         <p:nvSpPr>
-          <p:cNvPr id="7" name="TextBox 6" descr="Run 20261005T175406684735Z"/>
+          <p:cNvPr id="7" name="TextBox 6" descr="Run 20261006T015512364859Z"/>
           <p:cNvSpPr txBox="1"/>
           <p:nvPr/>
         </p:nvSpPr>
@@ -10880,7 +10880,7 @@
                 </a:solidFill>
                 <a:latin typeface="Arial"/>
               </a:rPr>
-              <a:t>Run 20261005T175406684735Z</a:t>
+              <a:t>Run 20261006T015512364859Z</a:t>
             </a:r>
           </a:p>
         </p:txBody>
@@ -13598,7 +13598,7 @@
       </p:sp>
       <p:sp>
         <p:nvSpPr>
-          <p:cNvPr id="7" name="TextBox 6" descr="Run 20261005T175406684735Z"/>
+          <p:cNvPr id="7" name="TextBox 6" descr="Run 20261006T015512364859Z"/>
           <p:cNvSpPr txBox="1"/>
           <p:nvPr/>
         </p:nvSpPr>
@@ -13626,7 +13626,7 @@
                 </a:solidFill>
                 <a:latin typeface="Arial"/>
               </a:rPr>
-              <a:t>Run 20261005T175406684735Z</a:t>
+              <a:t>Run 20261006T015512364859Z</a:t>
             </a:r>
           </a:p>
         </p:txBody>
@@ -16468,7 +16468,7 @@
       </p:sp>
       <p:sp>
         <p:nvSpPr>
-          <p:cNvPr id="7" name="TextBox 6" descr="Run 20261005T175406684735Z"/>
+          <p:cNvPr id="7" name="TextBox 6" descr="Run 20261006T015512364859Z"/>
           <p:cNvSpPr txBox="1"/>
           <p:nvPr/>
         </p:nvSpPr>
@@ -16496,7 +16496,7 @@
                 </a:solidFill>
                 <a:latin typeface="Arial"/>
               </a:rPr>
-              <a:t>Run 20261005T175406684735Z</a:t>
+              <a:t>Run 20261006T015512364859Z</a:t>
             </a:r>
           </a:p>
         </p:txBody>
@@ -18491,7 +18491,7 @@
       </p:sp>
       <p:sp>
         <p:nvSpPr>
-          <p:cNvPr id="7" name="TextBox 6" descr="Run 20261005T175406684735Z"/>
+          <p:cNvPr id="7" name="TextBox 6" descr="Run 20261006T015512364859Z"/>
           <p:cNvSpPr txBox="1"/>
           <p:nvPr/>
         </p:nvSpPr>
@@ -18519,7 +18519,7 @@
                 </a:solidFill>
                 <a:latin typeface="Arial"/>
               </a:rPr>
-              <a:t>Run 20261005T175406684735Z</a:t>
+              <a:t>Run 20261006T015512364859Z</a:t>
             </a:r>
           </a:p>
         </p:txBody>
@@ -20344,7 +20344,7 @@
       </p:sp>
       <p:sp>
         <p:nvSpPr>
-          <p:cNvPr id="7" name="TextBox 6" descr="Run 20261005T175406684735Z"/>
+          <p:cNvPr id="7" name="TextBox 6" descr="Run 20261006T015512364859Z"/>
           <p:cNvSpPr txBox="1"/>
           <p:nvPr/>
         </p:nvSpPr>
@@ -20372,7 +20372,7 @@
                 </a:solidFill>
                 <a:latin typeface="Arial"/>
               </a:rPr>
-              <a:t>Run 20261005T175406684735Z</a:t>
+              <a:t>Run 20261006T015512364859Z</a:t>
             </a:r>
           </a:p>
         </p:txBody>
@@ -22735,7 +22735,7 @@
       </p:sp>
       <p:sp>
         <p:nvSpPr>
-          <p:cNvPr id="7" name="TextBox 6" descr="Run 20261005T175406684735Z"/>
+          <p:cNvPr id="7" name="TextBox 6" descr="Run 20261006T015512364859Z"/>
           <p:cNvSpPr txBox="1"/>
           <p:nvPr/>
         </p:nvSpPr>
@@ -22763,7 +22763,7 @@
                 </a:solidFill>
                 <a:latin typeface="Arial"/>
               </a:rPr>
-              <a:t>Run 20261005T175406684735Z</a:t>
+              <a:t>Run 20261006T015512364859Z</a:t>
             </a:r>
           </a:p>
         </p:txBody>
@@ -23343,7 +23343,7 @@
       </p:sp>
       <p:sp>
         <p:nvSpPr>
-          <p:cNvPr id="19" name="TextBox 18" descr="20261005T175406684735Z"/>
+          <p:cNvPr id="19" name="TextBox 18" descr="20261006T015512364859Z"/>
           <p:cNvSpPr txBox="1"/>
           <p:nvPr/>
         </p:nvSpPr>
@@ -23371,7 +23371,7 @@
                 </a:solidFill>
                 <a:latin typeface="Arial"/>
               </a:rPr>
-              <a:t>20261005T175406684735Z</a:t>
+              <a:t>20261006T015512364859Z</a:t>
             </a:r>
           </a:p>
         </p:txBody>

</xml_diff>